<commit_message>
Remove names; tighten suppliers; SCDD 5-tier; richer assets; Excel restructure; 7-slide deck
</commit_message>
<xml_diff>
--- a/Glencore_Env_Risk_Tool_Deck.pptx
+++ b/Glencore_Env_Risk_Tool_Deck.pptx
@@ -12,8 +12,6 @@
     <p:sldId id="260" r:id="rId12"/>
     <p:sldId id="261" r:id="rId13"/>
     <p:sldId id="262" r:id="rId14"/>
-    <p:sldId id="263" r:id="rId15"/>
-    <p:sldId id="264" r:id="rId16"/>
   </p:sldIdLst>
   <p:sldSz cx="12191695" cy="6858000" type="screen4x3"/>
   <p:notesSz cx="6858000" cy="9144000"/>
@@ -580,7 +578,7 @@
           <a:lstStyle/>
           <a:p>
             <a:r>
-              <a:t>[Speaker 1, 1 min] Glencore engaged us to build a Tier 1 desktop research tool for environmental risk in their metals and minerals supply chain. The mandate had a few hard constraints: it had to automate the early steps of their existing OECD-aligned due diligence procedure — specifically Step 2A and 2B; it had to be non-technical so any RS analyst could use it; and every score had to come from a public, audit-able source so it could survive a CSRD or CSDDD review. We aligned our scoring methodology to ENCORE materiality and the IFC EHS Guidelines for process-level intensity. I'll now hand to [Speaker 2] for the geopolitical framing.</a:t>
+              <a:t>[Speaker 1, 1 min] Glencore — a global producer, processor, and marketer of transition-enabling metals and minerals — partnered with NYU's Center for Global Affairs to address a specific challenge: their existing due-diligence framework is human-rights-focused, but emerging EU regulation (CSRD, CSDDD, the Battery Regulation, the Consolidated Mining Standard) demands integrated environmental risk assessment. The operational constraint is acute: Glencore screens over 200,000 goods and services suppliers and 1,000+ metals and minerals suppliers with a very small team that cannot be subject-matter experts across every risk type. So scalability and a risk-based approach are essential. We anchored our work in the OECD Environmental DD Handbook, the RMI Plus Module, the UNDP Practical Tool for Business, and Glencore's own saliency framework. The deliverables are the guideline document, the end-to-end workflow, and what we'll show you today: a working tool prototype that operationalizes Tier 1. I'll now hand to [Speaker 2] for the geopolitical framing.</a:t>
             </a:r>
           </a:p>
         </p:txBody>
@@ -930,147 +928,7 @@
           <a:lstStyle/>
           <a:p>
             <a:r>
-              <a:t>[Speaker 2, 2 min] Concrete case study. Suppose an analyst gets a request to onboard a new cobalt supplier from the DRC. They open the tool, filter to Cobalt — DRC — Mining. Immediately three things happen. First, the CAHRA flag fires, automatically pushing this supplier from Tier 1 to Tier 2 of Glencore's SCDD procedure — that's non-discretionary. Second, the ranked table shows three Critical risks: tailings, soil pollution, and biodiversity loss. Each is audit-able — tailings comes from the Global Tailings Portal, soil pollution from ISRIC SoilGrids — DRC has highly acidic tropical soils that mobilize heavy metals — and biodiversity from IUCN Red List counts. Third, and this is the most operationally useful part: the Risk Library tab pre-loads the SAQ KPIs the analyst should ask the supplier — GISTM conformance, seepage rate in liters per day, heavy-metal soil concentrations. It also surfaces the likely supplier-type categories: earth moving, hazardous-chemical supplier, waste disposal. This collapses what was a multi-day desk-research exercise into about 10 minutes — and every number is auditable.</a:t>
-            </a:r>
-          </a:p>
-        </p:txBody>
-      </p:sp>
-      <p:sp>
-        <p:nvSpPr>
-          <p:cNvPr id="4" name="Slide Number Placeholder 3"/>
-          <p:cNvSpPr>
-            <a:spLocks noGrp="1"/>
-          </p:cNvSpPr>
-          <p:nvPr>
-            <p:ph type="sldNum" idx="5" sz="quarter"/>
-          </p:nvPr>
-        </p:nvSpPr>
-        <p:spPr/>
-      </p:sp>
-    </p:spTree>
-  </p:cSld>
-  <p:clrMapOvr>
-    <a:masterClrMapping/>
-  </p:clrMapOvr>
-</p:notes>
-</file>
-
-<file path=ppt/notesSlides/notesSlide8.xml><?xml version="1.0" encoding="utf-8"?>
-<p:notes xmlns:a="http://schemas.openxmlformats.org/drawingml/2006/main" xmlns:p="http://schemas.openxmlformats.org/presentationml/2006/main" xmlns:r="http://schemas.openxmlformats.org/officeDocument/2006/relationships">
-  <p:cSld>
-    <p:spTree>
-      <p:nvGrpSpPr>
-        <p:cNvPr id="1" name=""/>
-        <p:cNvGrpSpPr/>
-        <p:nvPr/>
-      </p:nvGrpSpPr>
-      <p:grpSpPr>
-        <a:xfrm>
-          <a:off x="0" y="0"/>
-          <a:ext cx="0" cy="0"/>
-          <a:chOff x="0" y="0"/>
-          <a:chExt cx="0" cy="0"/>
-        </a:xfrm>
-      </p:grpSpPr>
-      <p:sp>
-        <p:nvSpPr>
-          <p:cNvPr id="2" name="Slide Image Placeholder 1"/>
-          <p:cNvSpPr>
-            <a:spLocks noGrp="1"/>
-          </p:cNvSpPr>
-          <p:nvPr>
-            <p:ph type="sldImg" idx="2"/>
-          </p:nvPr>
-        </p:nvSpPr>
-        <p:spPr/>
-      </p:sp>
-      <p:sp>
-        <p:nvSpPr>
-          <p:cNvPr id="3" name="Notes Placeholder 2"/>
-          <p:cNvSpPr>
-            <a:spLocks noGrp="1"/>
-          </p:cNvSpPr>
-          <p:nvPr>
-            <p:ph type="body" idx="3" sz="quarter"/>
-          </p:nvPr>
-        </p:nvSpPr>
-        <p:spPr/>
-        <p:txBody>
-          <a:bodyPr/>
-          <a:lstStyle/>
-          <a:p>
-            <a:r>
-              <a:t>[Speaker 2, 1 min] The tool sits cleanly inside Glencore's existing SCDD workflow. Their procedure follows the OECD's five-step framework and breaks operational engagement into four tiers. Tier 1 is open-source desktop research — that's what we automate. Tier 2 is the supplier questionnaire — our Risk Library tab pre-populates the questions for that. Tier 3 is the onsite visit — our Critical-bucket rows tell the assessor where to focus. Tier 4 is the corrective action plan — our KPIs become CAP milestones. The point is: nothing in Glencore's existing process changes. The tool just makes the first three tiers faster and more reproducible.</a:t>
-            </a:r>
-          </a:p>
-        </p:txBody>
-      </p:sp>
-      <p:sp>
-        <p:nvSpPr>
-          <p:cNvPr id="4" name="Slide Number Placeholder 3"/>
-          <p:cNvSpPr>
-            <a:spLocks noGrp="1"/>
-          </p:cNvSpPr>
-          <p:nvPr>
-            <p:ph type="sldNum" idx="5" sz="quarter"/>
-          </p:nvPr>
-        </p:nvSpPr>
-        <p:spPr/>
-      </p:sp>
-    </p:spTree>
-  </p:cSld>
-  <p:clrMapOvr>
-    <a:masterClrMapping/>
-  </p:clrMapOvr>
-</p:notes>
-</file>
-
-<file path=ppt/notesSlides/notesSlide9.xml><?xml version="1.0" encoding="utf-8"?>
-<p:notes xmlns:a="http://schemas.openxmlformats.org/drawingml/2006/main" xmlns:p="http://schemas.openxmlformats.org/presentationml/2006/main" xmlns:r="http://schemas.openxmlformats.org/officeDocument/2006/relationships">
-  <p:cSld>
-    <p:spTree>
-      <p:nvGrpSpPr>
-        <p:cNvPr id="1" name=""/>
-        <p:cNvGrpSpPr/>
-        <p:nvPr/>
-      </p:nvGrpSpPr>
-      <p:grpSpPr>
-        <a:xfrm>
-          <a:off x="0" y="0"/>
-          <a:ext cx="0" cy="0"/>
-          <a:chOff x="0" y="0"/>
-          <a:chExt cx="0" cy="0"/>
-        </a:xfrm>
-      </p:grpSpPr>
-      <p:sp>
-        <p:nvSpPr>
-          <p:cNvPr id="2" name="Slide Image Placeholder 1"/>
-          <p:cNvSpPr>
-            <a:spLocks noGrp="1"/>
-          </p:cNvSpPr>
-          <p:nvPr>
-            <p:ph type="sldImg" idx="2"/>
-          </p:nvPr>
-        </p:nvSpPr>
-        <p:spPr/>
-      </p:sp>
-      <p:sp>
-        <p:nvSpPr>
-          <p:cNvPr id="3" name="Notes Placeholder 2"/>
-          <p:cNvSpPr>
-            <a:spLocks noGrp="1"/>
-          </p:cNvSpPr>
-          <p:nvPr>
-            <p:ph type="body" idx="3" sz="quarter"/>
-          </p:nvPr>
-        </p:nvSpPr>
-        <p:spPr/>
-        <p:txBody>
-          <a:bodyPr/>
-          <a:lstStyle/>
-          <a:p>
-            <a:r>
-              <a:t>[Speaker 1 closing, 30 sec] To wrap: the tool is on a public GitHub repo, deployed to a permanent Streamlit URL, ships with an 18-sheet Excel companion for analysts who don't want to run a web tool, and comes with a Docker container plus a written handover playbook for Glencore's IT team. Everything is editable in CSVs — no code skills required. We aimed to build something that survives the handover and stays useful as the geopolitical and energy-transition context keeps evolving. Happy to take questions.</a:t>
+              <a:t>[Speaker 2, 2 min — geopolitics deep dive] DRC × cobalt × mining is the single best case study to show why this tool matters in the geopolitics of the energy transition. Three layers stack here. First, energy-transition concentration: every electric vehicle battery cathode chemistry except LFP relies on cobalt, and the IEA forecasts 6× demand growth by 2040. Second, geographic concentration: 74 percent of mine production is in the DRC, and 70 percent of refining is in China — so a Western buyer is dependent on a single high-risk source country plus a single processing chokepoint that is itself subject to escalating U.S.–China trade restrictions. Third, regulatory pressure: the EU Battery Regulation that came into force in 2023 and the U.S. Inflation Reduction Act both treat cobalt traceability and environmental due diligence as gating items for market access. So this isn't optional — Glencore needs auditable Tier-1 evidence per supplier. The tool surfaces three Critical risks for any DRC cobalt mine: tailings, soil pollution — because DRC's tropical Oxisols mobilize heavy metals fast — and biodiversity loss. Every score links back to a public dataset, which is exactly what an EU CSDDD or CSRD audit will demand. That collapses a multi-day OSDR exercise into about ten minutes per supplier — and that's the scalability gap Glencore's small assessment team needs filled.</a:t>
             </a:r>
           </a:p>
         </p:txBody>
@@ -4293,13 +4151,13 @@
           <a:p>
             <a:pPr algn="l"/>
             <a:r>
-              <a:rPr sz="1200" b="0" i="0">
+              <a:rPr sz="1400" b="0" i="1">
                 <a:solidFill>
                   <a:srgbClr val="E0F2F1"/>
                 </a:solidFill>
                 <a:latin typeface="Calibri"/>
               </a:rPr>
-              <a:t>NYU School of Professional Studies  |  MS Global Affairs  |  Spring 2026</a:t>
+              <a:t>Glencore × NYU SPS Center for Global Affairs Consulting Practicum</a:t>
             </a:r>
           </a:p>
         </p:txBody>
@@ -4312,8 +4170,8 @@
         </p:nvSpPr>
         <p:spPr>
           <a:xfrm>
-            <a:off x="457200" y="5989320"/>
-            <a:ext cx="11247120" cy="365760"/>
+            <a:off x="457200" y="6035040"/>
+            <a:ext cx="11247120" cy="274320"/>
           </a:xfrm>
           <a:prstGeom prst="rect">
             <a:avLst/>
@@ -4328,13 +4186,13 @@
           <a:p>
             <a:pPr algn="l"/>
             <a:r>
-              <a:rPr sz="1000" b="0" i="1">
+              <a:rPr sz="1100" b="0" i="0">
                 <a:solidFill>
                   <a:srgbClr val="E0F2F1"/>
                 </a:solidFill>
                 <a:latin typeface="Calibri"/>
               </a:rPr>
-              <a:t>Marielle Markovitz · Maahi Gupta · Daniela Cano · Daniel Luis de Jesus · Lindsay Huba-Zhang · Zorana Ivanovich · Mohamad Rimawi</a:t>
+              <a:t>Spring 2026</a:t>
             </a:r>
           </a:p>
         </p:txBody>
@@ -4466,20 +4324,134 @@
                 </a:solidFill>
                 <a:latin typeface="Calibri"/>
               </a:rPr>
-              <a:t>What Glencore asked for · How we framed our response</a:t>
-            </a:r>
-          </a:p>
-        </p:txBody>
-      </p:sp>
-      <p:sp>
-        <p:nvSpPr>
-          <p:cNvPr id="5" name="TextBox 4"/>
-          <p:cNvSpPr txBox="1"/>
+              <a:t>Glencore × NYU SPS Consulting Practicum — Environmental Due Diligence Framework Development</a:t>
+            </a:r>
+          </a:p>
+        </p:txBody>
+      </p:sp>
+      <p:sp>
+        <p:nvSpPr>
+          <p:cNvPr id="5" name="Rectangle 4"/>
+          <p:cNvSpPr/>
           <p:nvPr/>
         </p:nvSpPr>
         <p:spPr>
           <a:xfrm>
             <a:off x="457200" y="1371600"/>
+            <a:ext cx="11247120" cy="868680"/>
+          </a:xfrm>
+          <a:prstGeom prst="rect">
+            <a:avLst/>
+          </a:prstGeom>
+          <a:solidFill>
+            <a:srgbClr val="E0F2F1"/>
+          </a:solidFill>
+          <a:ln>
+            <a:noFill/>
+          </a:ln>
+          <a:effectLst/>
+        </p:spPr>
+        <p:style>
+          <a:lnRef idx="1">
+            <a:schemeClr val="accent1"/>
+          </a:lnRef>
+          <a:fillRef idx="3">
+            <a:schemeClr val="accent1"/>
+          </a:fillRef>
+          <a:effectRef idx="2">
+            <a:schemeClr val="accent1"/>
+          </a:effectRef>
+          <a:fontRef idx="minor">
+            <a:schemeClr val="lt1"/>
+          </a:fontRef>
+        </p:style>
+        <p:txBody>
+          <a:bodyPr rtlCol="0" anchor="ctr"/>
+          <a:lstStyle/>
+          <a:p>
+            <a:pPr algn="ctr"/>
+          </a:p>
+        </p:txBody>
+      </p:sp>
+      <p:sp>
+        <p:nvSpPr>
+          <p:cNvPr id="6" name="TextBox 5"/>
+          <p:cNvSpPr txBox="1"/>
+          <p:nvPr/>
+        </p:nvSpPr>
+        <p:spPr>
+          <a:xfrm>
+            <a:off x="640080" y="1417320"/>
+            <a:ext cx="10972800" cy="320040"/>
+          </a:xfrm>
+          <a:prstGeom prst="rect">
+            <a:avLst/>
+          </a:prstGeom>
+          <a:noFill/>
+        </p:spPr>
+        <p:txBody>
+          <a:bodyPr wrap="square" anchor="t" lIns="45720" rIns="45720">
+            <a:spAutoFit/>
+          </a:bodyPr>
+          <a:lstStyle/>
+          <a:p>
+            <a:pPr algn="l"/>
+            <a:r>
+              <a:rPr sz="1400" b="1" i="0">
+                <a:solidFill>
+                  <a:srgbClr val="005F73"/>
+                </a:solidFill>
+                <a:latin typeface="Calibri"/>
+              </a:rPr>
+              <a:t>The challenge</a:t>
+            </a:r>
+          </a:p>
+        </p:txBody>
+      </p:sp>
+      <p:sp>
+        <p:nvSpPr>
+          <p:cNvPr id="7" name="TextBox 6"/>
+          <p:cNvSpPr txBox="1"/>
+          <p:nvPr/>
+        </p:nvSpPr>
+        <p:spPr>
+          <a:xfrm>
+            <a:off x="640080" y="1737360"/>
+            <a:ext cx="10972800" cy="502920"/>
+          </a:xfrm>
+          <a:prstGeom prst="rect">
+            <a:avLst/>
+          </a:prstGeom>
+          <a:noFill/>
+        </p:spPr>
+        <p:txBody>
+          <a:bodyPr wrap="square" anchor="t" lIns="45720" rIns="45720">
+            <a:spAutoFit/>
+          </a:bodyPr>
+          <a:lstStyle/>
+          <a:p>
+            <a:pPr algn="l"/>
+            <a:r>
+              <a:rPr sz="1100" b="0" i="0">
+                <a:solidFill>
+                  <a:srgbClr val="1A1A1A"/>
+                </a:solidFill>
+                <a:latin typeface="Calibri"/>
+              </a:rPr>
+              <a:t>Integrate environmental risk into Glencore's existing human-rights-focused due diligence framework. 200,000+ goods &amp; services suppliers and 1,000+ metals &amp; minerals suppliers; small assessment team that is not a subject-matter expert across every risk type. → Scalable, risk-based approach essential.</a:t>
+            </a:r>
+          </a:p>
+        </p:txBody>
+      </p:sp>
+      <p:sp>
+        <p:nvSpPr>
+          <p:cNvPr id="8" name="TextBox 7"/>
+          <p:cNvSpPr txBox="1"/>
+          <p:nvPr/>
+        </p:nvSpPr>
+        <p:spPr>
+          <a:xfrm>
+            <a:off x="457200" y="2423160"/>
             <a:ext cx="5486400" cy="365760"/>
           </a:xfrm>
           <a:prstGeom prst="rect">
@@ -4495,27 +4467,27 @@
           <a:p>
             <a:pPr algn="l"/>
             <a:r>
-              <a:rPr sz="1600" b="1" i="0">
+              <a:rPr sz="1400" b="1" i="0">
                 <a:solidFill>
                   <a:srgbClr val="005F73"/>
                 </a:solidFill>
                 <a:latin typeface="Calibri"/>
               </a:rPr>
-              <a:t>Mandate</a:t>
-            </a:r>
-          </a:p>
-        </p:txBody>
-      </p:sp>
-      <p:sp>
-        <p:nvSpPr>
-          <p:cNvPr id="6" name="TextBox 5"/>
-          <p:cNvSpPr txBox="1"/>
-          <p:nvPr/>
-        </p:nvSpPr>
-        <p:spPr>
-          <a:xfrm>
-            <a:off x="457200" y="1783080"/>
-            <a:ext cx="5486400" cy="4114800"/>
+              <a:t>Project objective</a:t>
+            </a:r>
+          </a:p>
+        </p:txBody>
+      </p:sp>
+      <p:sp>
+        <p:nvSpPr>
+          <p:cNvPr id="9" name="TextBox 8"/>
+          <p:cNvSpPr txBox="1"/>
+          <p:nvPr/>
+        </p:nvSpPr>
+        <p:spPr>
+          <a:xfrm>
+            <a:off x="457200" y="2788920"/>
+            <a:ext cx="5486400" cy="1828800"/>
           </a:xfrm>
           <a:prstGeom prst="rect">
             <a:avLst/>
@@ -4534,13 +4506,13 @@
               </a:lnSpc>
             </a:pPr>
             <a:r>
-              <a:rPr sz="1200" b="1">
+              <a:rPr sz="1100" b="1">
                 <a:solidFill>
                   <a:srgbClr val="1A1A1A"/>
                 </a:solidFill>
                 <a:latin typeface="Calibri"/>
               </a:rPr>
-              <a:t>• A pivot-style decision tool for Glencore's Group Responsible Sourcing team to support OECD-aligned Tier 1 due diligence</a:t>
+              <a:t>• Develop a practical, risk-based environmental due-diligence guideline and process workflow</a:t>
             </a:r>
           </a:p>
           <a:p>
@@ -4550,13 +4522,13 @@
               </a:lnSpc>
             </a:pPr>
             <a:r>
-              <a:rPr sz="1200" b="0">
+              <a:rPr sz="1100" b="0">
                 <a:solidFill>
                   <a:srgbClr val="1A1A1A"/>
                 </a:solidFill>
                 <a:latin typeface="Calibri"/>
               </a:rPr>
-              <a:t>• Cover the value chain end-to-end: mining → refining → smelting → recycling → marketing</a:t>
+              <a:t>• Build on Glencore's saliency-based risk framework</a:t>
             </a:r>
           </a:p>
           <a:p>
@@ -4566,13 +4538,13 @@
               </a:lnSpc>
             </a:pPr>
             <a:r>
-              <a:rPr sz="1200" b="0">
+              <a:rPr sz="1100" b="0">
                 <a:solidFill>
                   <a:srgbClr val="1A1A1A"/>
                 </a:solidFill>
                 <a:latin typeface="Calibri"/>
               </a:rPr>
-              <a:t>• Quantify outward environmental risks (penalties, fines, reputation) — not climate-on-company risks</a:t>
+              <a:t>• Account for very limited assessor resources</a:t>
             </a:r>
           </a:p>
           <a:p>
@@ -4582,15 +4554,73 @@
               </a:lnSpc>
             </a:pPr>
             <a:r>
-              <a:rPr sz="1200" b="0">
+              <a:rPr sz="1100" b="0">
                 <a:solidFill>
                   <a:srgbClr val="1A1A1A"/>
                 </a:solidFill>
                 <a:latin typeface="Calibri"/>
               </a:rPr>
-              <a:t>• Prioritise: water, waste, tailings, biodiversity, noise, air, soil</a:t>
-            </a:r>
-          </a:p>
+              <a:t>• Inform compliance with EU CSRD, CSDDD, EU Battery Regulation, and the Consolidated Mining Standard Initiative</a:t>
+            </a:r>
+          </a:p>
+        </p:txBody>
+      </p:sp>
+      <p:sp>
+        <p:nvSpPr>
+          <p:cNvPr id="10" name="TextBox 9"/>
+          <p:cNvSpPr txBox="1"/>
+          <p:nvPr/>
+        </p:nvSpPr>
+        <p:spPr>
+          <a:xfrm>
+            <a:off x="6400800" y="2423160"/>
+            <a:ext cx="5303520" cy="365760"/>
+          </a:xfrm>
+          <a:prstGeom prst="rect">
+            <a:avLst/>
+          </a:prstGeom>
+          <a:noFill/>
+        </p:spPr>
+        <p:txBody>
+          <a:bodyPr wrap="square" anchor="t" lIns="45720" rIns="45720">
+            <a:spAutoFit/>
+          </a:bodyPr>
+          <a:lstStyle/>
+          <a:p>
+            <a:pPr algn="l"/>
+            <a:r>
+              <a:rPr sz="1400" b="1" i="0">
+                <a:solidFill>
+                  <a:srgbClr val="005F73"/>
+                </a:solidFill>
+                <a:latin typeface="Calibri"/>
+              </a:rPr>
+              <a:t>Key research questions</a:t>
+            </a:r>
+          </a:p>
+        </p:txBody>
+      </p:sp>
+      <p:sp>
+        <p:nvSpPr>
+          <p:cNvPr id="11" name="TextBox 10"/>
+          <p:cNvSpPr txBox="1"/>
+          <p:nvPr/>
+        </p:nvSpPr>
+        <p:spPr>
+          <a:xfrm>
+            <a:off x="6400800" y="2788920"/>
+            <a:ext cx="5303520" cy="1828800"/>
+          </a:xfrm>
+          <a:prstGeom prst="rect">
+            <a:avLst/>
+          </a:prstGeom>
+          <a:noFill/>
+        </p:spPr>
+        <p:txBody>
+          <a:bodyPr wrap="square">
+            <a:spAutoFit/>
+          </a:bodyPr>
+          <a:lstStyle/>
           <a:p>
             <a:pPr algn="l">
               <a:lnSpc>
@@ -4598,13 +4628,13 @@
               </a:lnSpc>
             </a:pPr>
             <a:r>
-              <a:rPr sz="1200" b="0">
+              <a:rPr sz="1100" b="0">
                 <a:solidFill>
                   <a:srgbClr val="1A1A1A"/>
                 </a:solidFill>
                 <a:latin typeface="Calibri"/>
               </a:rPr>
-              <a:t>• Editable by non-technical analysts — Excel/Sheets-friendly</a:t>
+              <a:t>• How do we assess severity of environmental risk?</a:t>
             </a:r>
           </a:p>
           <a:p>
@@ -4614,73 +4644,15 @@
               </a:lnSpc>
             </a:pPr>
             <a:r>
-              <a:rPr sz="1200" b="0">
+              <a:rPr sz="1100" b="0">
                 <a:solidFill>
                   <a:srgbClr val="1A1A1A"/>
                 </a:solidFill>
                 <a:latin typeface="Calibri"/>
               </a:rPr>
-              <a:t>• Built on free, audit-able public data only</a:t>
-            </a:r>
-          </a:p>
-        </p:txBody>
-      </p:sp>
-      <p:sp>
-        <p:nvSpPr>
-          <p:cNvPr id="7" name="TextBox 6"/>
-          <p:cNvSpPr txBox="1"/>
-          <p:nvPr/>
-        </p:nvSpPr>
-        <p:spPr>
-          <a:xfrm>
-            <a:off x="6400800" y="1371600"/>
-            <a:ext cx="5303520" cy="365760"/>
-          </a:xfrm>
-          <a:prstGeom prst="rect">
-            <a:avLst/>
-          </a:prstGeom>
-          <a:noFill/>
-        </p:spPr>
-        <p:txBody>
-          <a:bodyPr wrap="square" anchor="t" lIns="45720" rIns="45720">
-            <a:spAutoFit/>
-          </a:bodyPr>
-          <a:lstStyle/>
-          <a:p>
-            <a:pPr algn="l"/>
-            <a:r>
-              <a:rPr sz="1600" b="1" i="0">
-                <a:solidFill>
-                  <a:srgbClr val="005F73"/>
-                </a:solidFill>
-                <a:latin typeface="Calibri"/>
-              </a:rPr>
-              <a:t>Frameworks aligned to</a:t>
-            </a:r>
-          </a:p>
-        </p:txBody>
-      </p:sp>
-      <p:sp>
-        <p:nvSpPr>
-          <p:cNvPr id="8" name="TextBox 7"/>
-          <p:cNvSpPr txBox="1"/>
-          <p:nvPr/>
-        </p:nvSpPr>
-        <p:spPr>
-          <a:xfrm>
-            <a:off x="6400800" y="1783080"/>
-            <a:ext cx="5303520" cy="4114800"/>
-          </a:xfrm>
-          <a:prstGeom prst="rect">
-            <a:avLst/>
-          </a:prstGeom>
-          <a:noFill/>
-        </p:spPr>
-        <p:txBody>
-          <a:bodyPr wrap="square">
-            <a:spAutoFit/>
-          </a:bodyPr>
-          <a:lstStyle/>
+              <a:t>• How do we prioritize among competing concerns?</a:t>
+            </a:r>
+          </a:p>
           <a:p>
             <a:pPr algn="l">
               <a:lnSpc>
@@ -4688,13 +4660,13 @@
               </a:lnSpc>
             </a:pPr>
             <a:r>
-              <a:rPr sz="1200" b="1">
+              <a:rPr sz="1100" b="1">
                 <a:solidFill>
                   <a:srgbClr val="1A1A1A"/>
                 </a:solidFill>
                 <a:latin typeface="Calibri"/>
               </a:rPr>
-              <a:t>• OECD Due Diligence Guidance for Responsible Supply Chains of Minerals (3rd ed., 2016)</a:t>
+              <a:t>• How do we translate risk identification into actionable due diligence with a small team?</a:t>
             </a:r>
           </a:p>
           <a:p>
@@ -4704,15 +4676,73 @@
               </a:lnSpc>
             </a:pPr>
             <a:r>
-              <a:rPr sz="1200" b="0">
+              <a:rPr sz="1100" b="0">
                 <a:solidFill>
                   <a:srgbClr val="1A1A1A"/>
                 </a:solidFill>
                 <a:latin typeface="Calibri"/>
               </a:rPr>
-              <a:t>• Glencore SCDD Procedure — Metals &amp; Minerals (2024) — automates Step 2A (Supplier/product scoping) and 2B/2C</a:t>
-            </a:r>
-          </a:p>
+              <a:t>• How does sector + jurisdiction influence prioritization (water scarcity, protected areas, hazardous materials)?</a:t>
+            </a:r>
+          </a:p>
+        </p:txBody>
+      </p:sp>
+      <p:sp>
+        <p:nvSpPr>
+          <p:cNvPr id="12" name="TextBox 11"/>
+          <p:cNvSpPr txBox="1"/>
+          <p:nvPr/>
+        </p:nvSpPr>
+        <p:spPr>
+          <a:xfrm>
+            <a:off x="457200" y="4709160"/>
+            <a:ext cx="5486400" cy="365760"/>
+          </a:xfrm>
+          <a:prstGeom prst="rect">
+            <a:avLst/>
+          </a:prstGeom>
+          <a:noFill/>
+        </p:spPr>
+        <p:txBody>
+          <a:bodyPr wrap="square" anchor="t" lIns="45720" rIns="45720">
+            <a:spAutoFit/>
+          </a:bodyPr>
+          <a:lstStyle/>
+          <a:p>
+            <a:pPr algn="l"/>
+            <a:r>
+              <a:rPr sz="1400" b="1" i="0">
+                <a:solidFill>
+                  <a:srgbClr val="005F73"/>
+                </a:solidFill>
+                <a:latin typeface="Calibri"/>
+              </a:rPr>
+              <a:t>Deliverables</a:t>
+            </a:r>
+          </a:p>
+        </p:txBody>
+      </p:sp>
+      <p:sp>
+        <p:nvSpPr>
+          <p:cNvPr id="13" name="TextBox 12"/>
+          <p:cNvSpPr txBox="1"/>
+          <p:nvPr/>
+        </p:nvSpPr>
+        <p:spPr>
+          <a:xfrm>
+            <a:off x="457200" y="5074920"/>
+            <a:ext cx="5486400" cy="914400"/>
+          </a:xfrm>
+          <a:prstGeom prst="rect">
+            <a:avLst/>
+          </a:prstGeom>
+          <a:noFill/>
+        </p:spPr>
+        <p:txBody>
+          <a:bodyPr wrap="square">
+            <a:spAutoFit/>
+          </a:bodyPr>
+          <a:lstStyle/>
           <a:p>
             <a:pPr algn="l">
               <a:lnSpc>
@@ -4720,13 +4750,13 @@
               </a:lnSpc>
             </a:pPr>
             <a:r>
-              <a:rPr sz="1200" b="0">
+              <a:rPr sz="1100" b="0">
                 <a:solidFill>
                   <a:srgbClr val="1A1A1A"/>
                 </a:solidFill>
                 <a:latin typeface="Calibri"/>
               </a:rPr>
-              <a:t>• EU CSRD + CSDDD reporting expectations</a:t>
+              <a:t>• 1. Environmental Due Diligence Guideline</a:t>
             </a:r>
           </a:p>
           <a:p>
@@ -4736,13 +4766,13 @@
               </a:lnSpc>
             </a:pPr>
             <a:r>
-              <a:rPr sz="1200" b="0">
+              <a:rPr sz="1100" b="0">
                 <a:solidFill>
                   <a:srgbClr val="1A1A1A"/>
                 </a:solidFill>
                 <a:latin typeface="Calibri"/>
               </a:rPr>
-              <a:t>• RMI Supply Chain Due Diligence Plus Module (April 2025)</a:t>
+              <a:t>• 2. End-to-end process workflow (visual)</a:t>
             </a:r>
           </a:p>
           <a:p>
@@ -4752,20 +4782,142 @@
               </a:lnSpc>
             </a:pPr>
             <a:r>
-              <a:rPr sz="1200" b="0">
+              <a:rPr sz="1100" b="0">
                 <a:solidFill>
                   <a:srgbClr val="1A1A1A"/>
                 </a:solidFill>
                 <a:latin typeface="Calibri"/>
               </a:rPr>
-              <a:t>• ENCORE materiality + IFC EHS Guidelines for process-level intensity</a:t>
-            </a:r>
-          </a:p>
-        </p:txBody>
-      </p:sp>
-      <p:sp>
-        <p:nvSpPr>
-          <p:cNvPr id="9" name="TextBox 8"/>
+              <a:t>• 3. This presentation + tool prototype</a:t>
+            </a:r>
+          </a:p>
+        </p:txBody>
+      </p:sp>
+      <p:sp>
+        <p:nvSpPr>
+          <p:cNvPr id="14" name="TextBox 13"/>
+          <p:cNvSpPr txBox="1"/>
+          <p:nvPr/>
+        </p:nvSpPr>
+        <p:spPr>
+          <a:xfrm>
+            <a:off x="6400800" y="4709160"/>
+            <a:ext cx="5303520" cy="365760"/>
+          </a:xfrm>
+          <a:prstGeom prst="rect">
+            <a:avLst/>
+          </a:prstGeom>
+          <a:noFill/>
+        </p:spPr>
+        <p:txBody>
+          <a:bodyPr wrap="square" anchor="t" lIns="45720" rIns="45720">
+            <a:spAutoFit/>
+          </a:bodyPr>
+          <a:lstStyle/>
+          <a:p>
+            <a:pPr algn="l"/>
+            <a:r>
+              <a:rPr sz="1400" b="1" i="0">
+                <a:solidFill>
+                  <a:srgbClr val="005F73"/>
+                </a:solidFill>
+                <a:latin typeface="Calibri"/>
+              </a:rPr>
+              <a:t>Anchor frameworks</a:t>
+            </a:r>
+          </a:p>
+        </p:txBody>
+      </p:sp>
+      <p:sp>
+        <p:nvSpPr>
+          <p:cNvPr id="15" name="TextBox 14"/>
+          <p:cNvSpPr txBox="1"/>
+          <p:nvPr/>
+        </p:nvSpPr>
+        <p:spPr>
+          <a:xfrm>
+            <a:off x="6400800" y="5074920"/>
+            <a:ext cx="5303520" cy="914400"/>
+          </a:xfrm>
+          <a:prstGeom prst="rect">
+            <a:avLst/>
+          </a:prstGeom>
+          <a:noFill/>
+        </p:spPr>
+        <p:txBody>
+          <a:bodyPr wrap="square">
+            <a:spAutoFit/>
+          </a:bodyPr>
+          <a:lstStyle/>
+          <a:p>
+            <a:pPr algn="l">
+              <a:lnSpc>
+                <a:spcPct val="118000"/>
+              </a:lnSpc>
+            </a:pPr>
+            <a:r>
+              <a:rPr sz="1100" b="0">
+                <a:solidFill>
+                  <a:srgbClr val="1A1A1A"/>
+                </a:solidFill>
+                <a:latin typeface="Calibri"/>
+              </a:rPr>
+              <a:t>• OECD Handbook on Environmental DD in Mineral Supply Chains (2023)</a:t>
+            </a:r>
+          </a:p>
+          <a:p>
+            <a:pPr algn="l">
+              <a:lnSpc>
+                <a:spcPct val="118000"/>
+              </a:lnSpc>
+            </a:pPr>
+            <a:r>
+              <a:rPr sz="1100" b="0">
+                <a:solidFill>
+                  <a:srgbClr val="1A1A1A"/>
+                </a:solidFill>
+                <a:latin typeface="Calibri"/>
+              </a:rPr>
+              <a:t>• RMI Supply Chain DD Plus Module (April 2025)</a:t>
+            </a:r>
+          </a:p>
+          <a:p>
+            <a:pPr algn="l">
+              <a:lnSpc>
+                <a:spcPct val="118000"/>
+              </a:lnSpc>
+            </a:pPr>
+            <a:r>
+              <a:rPr sz="1100" b="0">
+                <a:solidFill>
+                  <a:srgbClr val="1A1A1A"/>
+                </a:solidFill>
+                <a:latin typeface="Calibri"/>
+              </a:rPr>
+              <a:t>• UNDP HRDD and the Environment: A Practical Tool for Business</a:t>
+            </a:r>
+          </a:p>
+          <a:p>
+            <a:pPr algn="l">
+              <a:lnSpc>
+                <a:spcPct val="118000"/>
+              </a:lnSpc>
+            </a:pPr>
+            <a:r>
+              <a:rPr sz="1100" b="0">
+                <a:solidFill>
+                  <a:srgbClr val="1A1A1A"/>
+                </a:solidFill>
+                <a:latin typeface="Calibri"/>
+              </a:rPr>
+              <a:t>• Glencore's saliency-based risk framework + SCDD M&amp;M Procedure</a:t>
+            </a:r>
+          </a:p>
+        </p:txBody>
+      </p:sp>
+      <p:sp>
+        <p:nvSpPr>
+          <p:cNvPr id="16" name="TextBox 15"/>
           <p:cNvSpPr txBox="1"/>
           <p:nvPr/>
         </p:nvSpPr>
@@ -4793,14 +4945,14 @@
                 </a:solidFill>
                 <a:latin typeface="Calibri"/>
               </a:rPr>
-              <a:t>Sources: OECD DDG (oecd.org/daf/inv/mne/mining.htm); Glencore SCDD Procedure for Metals &amp; Minerals; RMI (responsiblemineralsinitiative.org).</a:t>
-            </a:r>
-          </a:p>
-        </p:txBody>
-      </p:sp>
-      <p:sp>
-        <p:nvSpPr>
-          <p:cNvPr id="10" name="TextBox 9"/>
+              <a:t>Source: Glencore × NYU Consulting Practicum project brief, NYU SPS Center for Global Affairs, 2026.</a:t>
+            </a:r>
+          </a:p>
+        </p:txBody>
+      </p:sp>
+      <p:sp>
+        <p:nvSpPr>
+          <p:cNvPr id="17" name="TextBox 16"/>
           <p:cNvSpPr txBox="1"/>
           <p:nvPr/>
         </p:nvSpPr>
@@ -4828,14 +4980,14 @@
                 </a:solidFill>
                 <a:latin typeface="Calibri"/>
               </a:rPr>
-              <a:t>Glencore Environmental Risk Tool — NYU SPS MS Global Affairs</a:t>
-            </a:r>
-          </a:p>
-        </p:txBody>
-      </p:sp>
-      <p:sp>
-        <p:nvSpPr>
-          <p:cNvPr id="11" name="TextBox 10"/>
+              <a:t>Glencore × NYU SPS Center for Global Affairs Consulting Practicum</a:t>
+            </a:r>
+          </a:p>
+        </p:txBody>
+      </p:sp>
+      <p:sp>
+        <p:nvSpPr>
+          <p:cNvPr id="18" name="TextBox 17"/>
           <p:cNvSpPr txBox="1"/>
           <p:nvPr/>
         </p:nvSpPr>
@@ -4863,7 +5015,7 @@
                 </a:solidFill>
                 <a:latin typeface="Calibri"/>
               </a:rPr>
-              <a:t>2 / 9</a:t>
+              <a:t>2 / 7</a:t>
             </a:r>
           </a:p>
         </p:txBody>
@@ -5643,7 +5795,7 @@
                 </a:solidFill>
                 <a:latin typeface="Calibri"/>
               </a:rPr>
-              <a:t>Glencore Environmental Risk Tool — NYU SPS MS Global Affairs</a:t>
+              <a:t>Glencore × NYU SPS Center for Global Affairs Consulting Practicum</a:t>
             </a:r>
           </a:p>
         </p:txBody>
@@ -5678,7 +5830,7 @@
                 </a:solidFill>
                 <a:latin typeface="Calibri"/>
               </a:rPr>
-              <a:t>3 / 9</a:t>
+              <a:t>3 / 7</a:t>
             </a:r>
           </a:p>
         </p:txBody>
@@ -9604,7 +9756,7 @@
                 </a:solidFill>
                 <a:latin typeface="Calibri"/>
               </a:rPr>
-              <a:t>Glencore Environmental Risk Tool — NYU SPS MS Global Affairs</a:t>
+              <a:t>Glencore × NYU SPS Center for Global Affairs Consulting Practicum</a:t>
             </a:r>
           </a:p>
         </p:txBody>
@@ -9639,7 +9791,7 @@
                 </a:solidFill>
                 <a:latin typeface="Calibri"/>
               </a:rPr>
-              <a:t>4 / 9</a:t>
+              <a:t>4 / 7</a:t>
             </a:r>
           </a:p>
         </p:txBody>
@@ -10003,7 +10155,7 @@
                 </a:solidFill>
                 <a:latin typeface="Calibri"/>
               </a:rPr>
-              <a:t>Glencore Environmental Risk Tool — NYU SPS MS Global Affairs</a:t>
+              <a:t>Glencore × NYU SPS Center for Global Affairs Consulting Practicum</a:t>
             </a:r>
           </a:p>
         </p:txBody>
@@ -10038,7 +10190,7 @@
                 </a:solidFill>
                 <a:latin typeface="Calibri"/>
               </a:rPr>
-              <a:t>5 / 9</a:t>
+              <a:t>5 / 7</a:t>
             </a:r>
           </a:p>
         </p:txBody>
@@ -10915,7 +11067,7 @@
                 </a:solidFill>
                 <a:latin typeface="Calibri"/>
               </a:rPr>
-              <a:t>Glencore Environmental Risk Tool — NYU SPS MS Global Affairs</a:t>
+              <a:t>Glencore × NYU SPS Center for Global Affairs Consulting Practicum</a:t>
             </a:r>
           </a:p>
         </p:txBody>
@@ -10950,7 +11102,7 @@
                 </a:solidFill>
                 <a:latin typeface="Calibri"/>
               </a:rPr>
-              <a:t>6 / 9</a:t>
+              <a:t>6 / 7</a:t>
             </a:r>
           </a:p>
         </p:txBody>
@@ -11047,7 +11199,7 @@
                 </a:solidFill>
                 <a:latin typeface="Calibri"/>
               </a:rPr>
-              <a:t>Case study — DRC × Cobalt × Mining</a:t>
+              <a:t>Geopolitics deep dive — DRC × Cobalt × Mining</a:t>
             </a:r>
           </a:p>
         </p:txBody>
@@ -11082,14 +11234,608 @@
                 </a:solidFill>
                 <a:latin typeface="Calibri"/>
               </a:rPr>
-              <a:t>How a Glencore Responsible Sourcing analyst uses the tool in practice</a:t>
+              <a:t>Why this combination is the canonical stress-test for the energy transition</a:t>
+            </a:r>
+          </a:p>
+        </p:txBody>
+      </p:sp>
+      <p:sp>
+        <p:nvSpPr>
+          <p:cNvPr id="5" name="Rectangle 4"/>
+          <p:cNvSpPr/>
+          <p:nvPr/>
+        </p:nvSpPr>
+        <p:spPr>
+          <a:xfrm>
+            <a:off x="457200" y="1280160"/>
+            <a:ext cx="2788920" cy="1508760"/>
+          </a:xfrm>
+          <a:prstGeom prst="rect">
+            <a:avLst/>
+          </a:prstGeom>
+          <a:solidFill>
+            <a:srgbClr val="005F73"/>
+          </a:solidFill>
+          <a:ln>
+            <a:noFill/>
+          </a:ln>
+          <a:effectLst/>
+        </p:spPr>
+        <p:style>
+          <a:lnRef idx="1">
+            <a:schemeClr val="accent1"/>
+          </a:lnRef>
+          <a:fillRef idx="3">
+            <a:schemeClr val="accent1"/>
+          </a:fillRef>
+          <a:effectRef idx="2">
+            <a:schemeClr val="accent1"/>
+          </a:effectRef>
+          <a:fontRef idx="minor">
+            <a:schemeClr val="lt1"/>
+          </a:fontRef>
+        </p:style>
+        <p:txBody>
+          <a:bodyPr rtlCol="0" anchor="ctr"/>
+          <a:lstStyle/>
+          <a:p>
+            <a:pPr algn="ctr"/>
+          </a:p>
+        </p:txBody>
+      </p:sp>
+      <p:sp>
+        <p:nvSpPr>
+          <p:cNvPr id="6" name="TextBox 5"/>
+          <p:cNvSpPr txBox="1"/>
+          <p:nvPr/>
+        </p:nvSpPr>
+        <p:spPr>
+          <a:xfrm>
+            <a:off x="457200" y="1371600"/>
+            <a:ext cx="2788920" cy="731520"/>
+          </a:xfrm>
+          <a:prstGeom prst="rect">
+            <a:avLst/>
+          </a:prstGeom>
+          <a:noFill/>
+        </p:spPr>
+        <p:txBody>
+          <a:bodyPr wrap="square" anchor="t" lIns="45720" rIns="45720">
+            <a:spAutoFit/>
+          </a:bodyPr>
+          <a:lstStyle/>
+          <a:p>
+            <a:pPr algn="ctr"/>
+            <a:r>
+              <a:rPr sz="3200" b="1" i="0">
+                <a:solidFill>
+                  <a:srgbClr val="FFFFFF"/>
+                </a:solidFill>
+                <a:latin typeface="Calibri"/>
+              </a:rPr>
+              <a:t>74%</a:t>
+            </a:r>
+          </a:p>
+        </p:txBody>
+      </p:sp>
+      <p:sp>
+        <p:nvSpPr>
+          <p:cNvPr id="7" name="TextBox 6"/>
+          <p:cNvSpPr txBox="1"/>
+          <p:nvPr/>
+        </p:nvSpPr>
+        <p:spPr>
+          <a:xfrm>
+            <a:off x="457200" y="2148840"/>
+            <a:ext cx="2788920" cy="731520"/>
+          </a:xfrm>
+          <a:prstGeom prst="rect">
+            <a:avLst/>
+          </a:prstGeom>
+          <a:noFill/>
+        </p:spPr>
+        <p:txBody>
+          <a:bodyPr wrap="square" anchor="t" lIns="45720" rIns="45720">
+            <a:spAutoFit/>
+          </a:bodyPr>
+          <a:lstStyle/>
+          <a:p>
+            <a:pPr algn="ctr"/>
+            <a:r>
+              <a:rPr sz="1000" b="0" i="0">
+                <a:solidFill>
+                  <a:srgbClr val="FFFFFF"/>
+                </a:solidFill>
+                <a:latin typeface="Calibri"/>
+              </a:rPr>
+              <a:t>DRC's share of global cobalt mine production (USGS MCS 2024)</a:t>
+            </a:r>
+          </a:p>
+        </p:txBody>
+      </p:sp>
+      <p:sp>
+        <p:nvSpPr>
+          <p:cNvPr id="8" name="Rectangle 7"/>
+          <p:cNvSpPr/>
+          <p:nvPr/>
+        </p:nvSpPr>
+        <p:spPr>
+          <a:xfrm>
+            <a:off x="3337560" y="1280160"/>
+            <a:ext cx="2788920" cy="1508760"/>
+          </a:xfrm>
+          <a:prstGeom prst="rect">
+            <a:avLst/>
+          </a:prstGeom>
+          <a:solidFill>
+            <a:srgbClr val="00A9A5"/>
+          </a:solidFill>
+          <a:ln>
+            <a:noFill/>
+          </a:ln>
+          <a:effectLst/>
+        </p:spPr>
+        <p:style>
+          <a:lnRef idx="1">
+            <a:schemeClr val="accent1"/>
+          </a:lnRef>
+          <a:fillRef idx="3">
+            <a:schemeClr val="accent1"/>
+          </a:fillRef>
+          <a:effectRef idx="2">
+            <a:schemeClr val="accent1"/>
+          </a:effectRef>
+          <a:fontRef idx="minor">
+            <a:schemeClr val="lt1"/>
+          </a:fontRef>
+        </p:style>
+        <p:txBody>
+          <a:bodyPr rtlCol="0" anchor="ctr"/>
+          <a:lstStyle/>
+          <a:p>
+            <a:pPr algn="ctr"/>
+          </a:p>
+        </p:txBody>
+      </p:sp>
+      <p:sp>
+        <p:nvSpPr>
+          <p:cNvPr id="9" name="TextBox 8"/>
+          <p:cNvSpPr txBox="1"/>
+          <p:nvPr/>
+        </p:nvSpPr>
+        <p:spPr>
+          <a:xfrm>
+            <a:off x="3337560" y="1371600"/>
+            <a:ext cx="2788920" cy="731520"/>
+          </a:xfrm>
+          <a:prstGeom prst="rect">
+            <a:avLst/>
+          </a:prstGeom>
+          <a:noFill/>
+        </p:spPr>
+        <p:txBody>
+          <a:bodyPr wrap="square" anchor="t" lIns="45720" rIns="45720">
+            <a:spAutoFit/>
+          </a:bodyPr>
+          <a:lstStyle/>
+          <a:p>
+            <a:pPr algn="ctr"/>
+            <a:r>
+              <a:rPr sz="3200" b="1" i="0">
+                <a:solidFill>
+                  <a:srgbClr val="FFFFFF"/>
+                </a:solidFill>
+                <a:latin typeface="Calibri"/>
+              </a:rPr>
+              <a:t>All regions</a:t>
+            </a:r>
+          </a:p>
+        </p:txBody>
+      </p:sp>
+      <p:sp>
+        <p:nvSpPr>
+          <p:cNvPr id="10" name="TextBox 9"/>
+          <p:cNvSpPr txBox="1"/>
+          <p:nvPr/>
+        </p:nvSpPr>
+        <p:spPr>
+          <a:xfrm>
+            <a:off x="3337560" y="2148840"/>
+            <a:ext cx="2788920" cy="731520"/>
+          </a:xfrm>
+          <a:prstGeom prst="rect">
+            <a:avLst/>
+          </a:prstGeom>
+          <a:noFill/>
+        </p:spPr>
+        <p:txBody>
+          <a:bodyPr wrap="square" anchor="t" lIns="45720" rIns="45720">
+            <a:spAutoFit/>
+          </a:bodyPr>
+          <a:lstStyle/>
+          <a:p>
+            <a:pPr algn="ctr"/>
+            <a:r>
+              <a:rPr sz="1000" b="0" i="0">
+                <a:solidFill>
+                  <a:srgbClr val="FFFFFF"/>
+                </a:solidFill>
+                <a:latin typeface="Calibri"/>
+              </a:rPr>
+              <a:t>Glencore CAHRA flag — every Congolese province is high-risk</a:t>
+            </a:r>
+          </a:p>
+        </p:txBody>
+      </p:sp>
+      <p:sp>
+        <p:nvSpPr>
+          <p:cNvPr id="11" name="Rectangle 10"/>
+          <p:cNvSpPr/>
+          <p:nvPr/>
+        </p:nvSpPr>
+        <p:spPr>
+          <a:xfrm>
+            <a:off x="6217920" y="1280160"/>
+            <a:ext cx="2788920" cy="1508760"/>
+          </a:xfrm>
+          <a:prstGeom prst="rect">
+            <a:avLst/>
+          </a:prstGeom>
+          <a:solidFill>
+            <a:srgbClr val="005F73"/>
+          </a:solidFill>
+          <a:ln>
+            <a:noFill/>
+          </a:ln>
+          <a:effectLst/>
+        </p:spPr>
+        <p:style>
+          <a:lnRef idx="1">
+            <a:schemeClr val="accent1"/>
+          </a:lnRef>
+          <a:fillRef idx="3">
+            <a:schemeClr val="accent1"/>
+          </a:fillRef>
+          <a:effectRef idx="2">
+            <a:schemeClr val="accent1"/>
+          </a:effectRef>
+          <a:fontRef idx="minor">
+            <a:schemeClr val="lt1"/>
+          </a:fontRef>
+        </p:style>
+        <p:txBody>
+          <a:bodyPr rtlCol="0" anchor="ctr"/>
+          <a:lstStyle/>
+          <a:p>
+            <a:pPr algn="ctr"/>
+          </a:p>
+        </p:txBody>
+      </p:sp>
+      <p:sp>
+        <p:nvSpPr>
+          <p:cNvPr id="12" name="TextBox 11"/>
+          <p:cNvSpPr txBox="1"/>
+          <p:nvPr/>
+        </p:nvSpPr>
+        <p:spPr>
+          <a:xfrm>
+            <a:off x="6217920" y="1371600"/>
+            <a:ext cx="2788920" cy="731520"/>
+          </a:xfrm>
+          <a:prstGeom prst="rect">
+            <a:avLst/>
+          </a:prstGeom>
+          <a:noFill/>
+        </p:spPr>
+        <p:txBody>
+          <a:bodyPr wrap="square" anchor="t" lIns="45720" rIns="45720">
+            <a:spAutoFit/>
+          </a:bodyPr>
+          <a:lstStyle/>
+          <a:p>
+            <a:pPr algn="ctr"/>
+            <a:r>
+              <a:rPr sz="3200" b="1" i="0">
+                <a:solidFill>
+                  <a:srgbClr val="FFFFFF"/>
+                </a:solidFill>
+                <a:latin typeface="Calibri"/>
+              </a:rPr>
+              <a:t>~2 of 5</a:t>
+            </a:r>
+          </a:p>
+        </p:txBody>
+      </p:sp>
+      <p:sp>
+        <p:nvSpPr>
+          <p:cNvPr id="13" name="TextBox 12"/>
+          <p:cNvSpPr txBox="1"/>
+          <p:nvPr/>
+        </p:nvSpPr>
+        <p:spPr>
+          <a:xfrm>
+            <a:off x="6217920" y="2148840"/>
+            <a:ext cx="2788920" cy="731520"/>
+          </a:xfrm>
+          <a:prstGeom prst="rect">
+            <a:avLst/>
+          </a:prstGeom>
+          <a:noFill/>
+        </p:spPr>
+        <p:txBody>
+          <a:bodyPr wrap="square" anchor="t" lIns="45720" rIns="45720">
+            <a:spAutoFit/>
+          </a:bodyPr>
+          <a:lstStyle/>
+          <a:p>
+            <a:pPr algn="ctr"/>
+            <a:r>
+              <a:rPr sz="1000" b="0" i="0">
+                <a:solidFill>
+                  <a:srgbClr val="FFFFFF"/>
+                </a:solidFill>
+                <a:latin typeface="Calibri"/>
+              </a:rPr>
+              <a:t>of every EV battery's cathode chemistry depends on cobalt</a:t>
+            </a:r>
+          </a:p>
+        </p:txBody>
+      </p:sp>
+      <p:sp>
+        <p:nvSpPr>
+          <p:cNvPr id="14" name="Rectangle 13"/>
+          <p:cNvSpPr/>
+          <p:nvPr/>
+        </p:nvSpPr>
+        <p:spPr>
+          <a:xfrm>
+            <a:off x="9098280" y="1280160"/>
+            <a:ext cx="2788920" cy="1508760"/>
+          </a:xfrm>
+          <a:prstGeom prst="rect">
+            <a:avLst/>
+          </a:prstGeom>
+          <a:solidFill>
+            <a:srgbClr val="00A9A5"/>
+          </a:solidFill>
+          <a:ln>
+            <a:noFill/>
+          </a:ln>
+          <a:effectLst/>
+        </p:spPr>
+        <p:style>
+          <a:lnRef idx="1">
+            <a:schemeClr val="accent1"/>
+          </a:lnRef>
+          <a:fillRef idx="3">
+            <a:schemeClr val="accent1"/>
+          </a:fillRef>
+          <a:effectRef idx="2">
+            <a:schemeClr val="accent1"/>
+          </a:effectRef>
+          <a:fontRef idx="minor">
+            <a:schemeClr val="lt1"/>
+          </a:fontRef>
+        </p:style>
+        <p:txBody>
+          <a:bodyPr rtlCol="0" anchor="ctr"/>
+          <a:lstStyle/>
+          <a:p>
+            <a:pPr algn="ctr"/>
+          </a:p>
+        </p:txBody>
+      </p:sp>
+      <p:sp>
+        <p:nvSpPr>
+          <p:cNvPr id="15" name="TextBox 14"/>
+          <p:cNvSpPr txBox="1"/>
+          <p:nvPr/>
+        </p:nvSpPr>
+        <p:spPr>
+          <a:xfrm>
+            <a:off x="9098280" y="1371600"/>
+            <a:ext cx="2788920" cy="731520"/>
+          </a:xfrm>
+          <a:prstGeom prst="rect">
+            <a:avLst/>
+          </a:prstGeom>
+          <a:noFill/>
+        </p:spPr>
+        <p:txBody>
+          <a:bodyPr wrap="square" anchor="t" lIns="45720" rIns="45720">
+            <a:spAutoFit/>
+          </a:bodyPr>
+          <a:lstStyle/>
+          <a:p>
+            <a:pPr algn="ctr"/>
+            <a:r>
+              <a:rPr sz="3200" b="1" i="0">
+                <a:solidFill>
+                  <a:srgbClr val="FFFFFF"/>
+                </a:solidFill>
+                <a:latin typeface="Calibri"/>
+              </a:rPr>
+              <a:t>Tier 2</a:t>
+            </a:r>
+          </a:p>
+        </p:txBody>
+      </p:sp>
+      <p:sp>
+        <p:nvSpPr>
+          <p:cNvPr id="16" name="TextBox 15"/>
+          <p:cNvSpPr txBox="1"/>
+          <p:nvPr/>
+        </p:nvSpPr>
+        <p:spPr>
+          <a:xfrm>
+            <a:off x="9098280" y="2148840"/>
+            <a:ext cx="2788920" cy="731520"/>
+          </a:xfrm>
+          <a:prstGeom prst="rect">
+            <a:avLst/>
+          </a:prstGeom>
+          <a:noFill/>
+        </p:spPr>
+        <p:txBody>
+          <a:bodyPr wrap="square" anchor="t" lIns="45720" rIns="45720">
+            <a:spAutoFit/>
+          </a:bodyPr>
+          <a:lstStyle/>
+          <a:p>
+            <a:pPr algn="ctr"/>
+            <a:r>
+              <a:rPr sz="1000" b="0" i="0">
+                <a:solidFill>
+                  <a:srgbClr val="FFFFFF"/>
+                </a:solidFill>
+                <a:latin typeface="Calibri"/>
+              </a:rPr>
+              <a:t>auto-trigger: any DRC supplier escalates immediately under SCDD M&amp;M procedure</a:t>
+            </a:r>
+          </a:p>
+        </p:txBody>
+      </p:sp>
+      <p:sp>
+        <p:nvSpPr>
+          <p:cNvPr id="17" name="TextBox 16"/>
+          <p:cNvSpPr txBox="1"/>
+          <p:nvPr/>
+        </p:nvSpPr>
+        <p:spPr>
+          <a:xfrm>
+            <a:off x="457200" y="2926080"/>
+            <a:ext cx="5486400" cy="365760"/>
+          </a:xfrm>
+          <a:prstGeom prst="rect">
+            <a:avLst/>
+          </a:prstGeom>
+          <a:noFill/>
+        </p:spPr>
+        <p:txBody>
+          <a:bodyPr wrap="square" anchor="t" lIns="45720" rIns="45720">
+            <a:spAutoFit/>
+          </a:bodyPr>
+          <a:lstStyle/>
+          <a:p>
+            <a:pPr algn="l"/>
+            <a:r>
+              <a:rPr sz="1400" b="1" i="0">
+                <a:solidFill>
+                  <a:srgbClr val="005F73"/>
+                </a:solidFill>
+                <a:latin typeface="Calibri"/>
+              </a:rPr>
+              <a:t>Why DRC × cobalt is structurally exposed</a:t>
+            </a:r>
+          </a:p>
+        </p:txBody>
+      </p:sp>
+      <p:sp>
+        <p:nvSpPr>
+          <p:cNvPr id="18" name="TextBox 17"/>
+          <p:cNvSpPr txBox="1"/>
+          <p:nvPr/>
+        </p:nvSpPr>
+        <p:spPr>
+          <a:xfrm>
+            <a:off x="457200" y="3291840"/>
+            <a:ext cx="5486400" cy="2926080"/>
+          </a:xfrm>
+          <a:prstGeom prst="rect">
+            <a:avLst/>
+          </a:prstGeom>
+          <a:noFill/>
+        </p:spPr>
+        <p:txBody>
+          <a:bodyPr wrap="square">
+            <a:spAutoFit/>
+          </a:bodyPr>
+          <a:lstStyle/>
+          <a:p>
+            <a:pPr algn="l">
+              <a:lnSpc>
+                <a:spcPct val="118000"/>
+              </a:lnSpc>
+            </a:pPr>
+            <a:r>
+              <a:rPr sz="1100" b="1">
+                <a:solidFill>
+                  <a:srgbClr val="1A1A1A"/>
+                </a:solidFill>
+                <a:latin typeface="Calibri"/>
+              </a:rPr>
+              <a:t>• Energy transition concentration: cobalt for EV batteries, grid storage. IEA forecasts demand 6× by 2040.</a:t>
+            </a:r>
+          </a:p>
+          <a:p>
+            <a:pPr algn="l">
+              <a:lnSpc>
+                <a:spcPct val="118000"/>
+              </a:lnSpc>
+            </a:pPr>
+            <a:r>
+              <a:rPr sz="1100" b="1">
+                <a:solidFill>
+                  <a:srgbClr val="1A1A1A"/>
+                </a:solidFill>
+                <a:latin typeface="Calibri"/>
+              </a:rPr>
+              <a:t>• Geographic concentration: DRC produces ~74%; refining ~70% China-controlled. Western buyers face cross-strait + cross-border policy exposure.</a:t>
+            </a:r>
+          </a:p>
+          <a:p>
+            <a:pPr algn="l">
+              <a:lnSpc>
+                <a:spcPct val="118000"/>
+              </a:lnSpc>
+            </a:pPr>
+            <a:r>
+              <a:rPr sz="1100" b="0">
+                <a:solidFill>
+                  <a:srgbClr val="1A1A1A"/>
+                </a:solidFill>
+                <a:latin typeface="Calibri"/>
+              </a:rPr>
+              <a:t>• EU Battery Regulation (EU 2023/1542) and the U.S. Inflation Reduction Act both treat cobalt traceability and DD as compliance gating items for market access.</a:t>
+            </a:r>
+          </a:p>
+          <a:p>
+            <a:pPr algn="l">
+              <a:lnSpc>
+                <a:spcPct val="118000"/>
+              </a:lnSpc>
+            </a:pPr>
+            <a:r>
+              <a:rPr sz="1100" b="0">
+                <a:solidFill>
+                  <a:srgbClr val="1A1A1A"/>
+                </a:solidFill>
+                <a:latin typeface="Calibri"/>
+              </a:rPr>
+              <a:t>• Artisanal &amp; small-scale mining (ASM) supplies ~15-30% of DRC cobalt — child labor and fatality risk make environmental + human-rights DD inseparable.</a:t>
+            </a:r>
+          </a:p>
+          <a:p>
+            <a:pPr algn="l">
+              <a:lnSpc>
+                <a:spcPct val="118000"/>
+              </a:lnSpc>
+            </a:pPr>
+            <a:r>
+              <a:rPr sz="1100" b="0">
+                <a:solidFill>
+                  <a:srgbClr val="1A1A1A"/>
+                </a:solidFill>
+                <a:latin typeface="Calibri"/>
+              </a:rPr>
+              <a:t>• Acidic tropical Oxisols → highest soil-pollution vulnerability in the dataset; spilled heavy metals mobilize fast (ISRIC SoilGrids vulnerability ≈ 4.3 / 5).</a:t>
             </a:r>
           </a:p>
         </p:txBody>
       </p:sp>
       <p:pic>
         <p:nvPicPr>
-          <p:cNvPr id="5" name="Picture 4" descr="02_map.png"/>
+          <p:cNvPr id="19" name="Picture 18" descr="01_dashboard.png"/>
           <p:cNvPicPr>
             <a:picLocks noChangeAspect="1"/>
           </p:cNvPicPr>
@@ -11103,8 +11849,8 @@
         </p:blipFill>
         <p:spPr>
           <a:xfrm>
-            <a:off x="365760" y="1188720"/>
-            <a:ext cx="4655127" cy="3200400"/>
+            <a:off x="6263640" y="2926080"/>
+            <a:ext cx="4522124" cy="3108960"/>
           </a:xfrm>
           <a:prstGeom prst="rect">
             <a:avLst/>
@@ -11113,14 +11859,14 @@
       </p:pic>
       <p:sp>
         <p:nvSpPr>
-          <p:cNvPr id="6" name="TextBox 5"/>
-          <p:cNvSpPr txBox="1"/>
-          <p:nvPr/>
-        </p:nvSpPr>
-        <p:spPr>
-          <a:xfrm>
-            <a:off x="457200" y="4526280"/>
-            <a:ext cx="11247120" cy="365760"/>
+          <p:cNvPr id="20" name="TextBox 19"/>
+          <p:cNvSpPr txBox="1"/>
+          <p:nvPr/>
+        </p:nvSpPr>
+        <p:spPr>
+          <a:xfrm>
+            <a:off x="6263640" y="5989320"/>
+            <a:ext cx="5486400" cy="274320"/>
           </a:xfrm>
           <a:prstGeom prst="rect">
             <a:avLst/>
@@ -11135,185 +11881,62 @@
           <a:p>
             <a:pPr algn="l"/>
             <a:r>
-              <a:rPr sz="1400" b="1" i="0">
-                <a:solidFill>
-                  <a:srgbClr val="005F73"/>
-                </a:solidFill>
-                <a:latin typeface="Calibri"/>
-              </a:rPr>
-              <a:t>What the tool surfaces (filter: Cobalt + DRC + Mining)</a:t>
-            </a:r>
-          </a:p>
-        </p:txBody>
-      </p:sp>
-      <p:sp>
-        <p:nvSpPr>
-          <p:cNvPr id="7" name="TextBox 6"/>
-          <p:cNvSpPr txBox="1"/>
-          <p:nvPr/>
-        </p:nvSpPr>
-        <p:spPr>
-          <a:xfrm>
-            <a:off x="457200" y="4892040"/>
-            <a:ext cx="5486400" cy="1554480"/>
-          </a:xfrm>
-          <a:prstGeom prst="rect">
-            <a:avLst/>
-          </a:prstGeom>
-          <a:noFill/>
-        </p:spPr>
-        <p:txBody>
-          <a:bodyPr wrap="square">
-            <a:spAutoFit/>
-          </a:bodyPr>
-          <a:lstStyle/>
-          <a:p>
-            <a:pPr algn="l">
-              <a:lnSpc>
-                <a:spcPct val="118000"/>
-              </a:lnSpc>
-            </a:pPr>
-            <a:r>
-              <a:rPr sz="1100" b="0">
+              <a:rPr sz="1000" b="0" i="1">
+                <a:solidFill>
+                  <a:srgbClr val="555555"/>
+                </a:solidFill>
+                <a:latin typeface="Calibri"/>
+              </a:rPr>
+              <a:t>Live tool view: DRC × Cobalt × Mining → 3 Critical risks</a:t>
+            </a:r>
+          </a:p>
+        </p:txBody>
+      </p:sp>
+      <p:sp>
+        <p:nvSpPr>
+          <p:cNvPr id="21" name="TextBox 20"/>
+          <p:cNvSpPr txBox="1"/>
+          <p:nvPr/>
+        </p:nvSpPr>
+        <p:spPr>
+          <a:xfrm>
+            <a:off x="457200" y="6263640"/>
+            <a:ext cx="11247120" cy="274320"/>
+          </a:xfrm>
+          <a:prstGeom prst="rect">
+            <a:avLst/>
+          </a:prstGeom>
+          <a:noFill/>
+        </p:spPr>
+        <p:txBody>
+          <a:bodyPr wrap="square" anchor="t" lIns="45720" rIns="45720">
+            <a:spAutoFit/>
+          </a:bodyPr>
+          <a:lstStyle/>
+          <a:p>
+            <a:pPr algn="l"/>
+            <a:r>
+              <a:rPr sz="1000" b="0" i="0">
                 <a:solidFill>
                   <a:srgbClr val="1A1A1A"/>
                 </a:solidFill>
                 <a:latin typeface="Calibri"/>
               </a:rPr>
-              <a:t>• 🚩 CAHRA flag (All regions) → automatic Tier 1 → Tier 2 escalation</a:t>
-            </a:r>
-          </a:p>
-          <a:p>
-            <a:pPr algn="l">
-              <a:lnSpc>
-                <a:spcPct val="118000"/>
-              </a:lnSpc>
-            </a:pPr>
-            <a:r>
-              <a:rPr sz="1100" b="0">
-                <a:solidFill>
-                  <a:srgbClr val="1A1A1A"/>
-                </a:solidFill>
-                <a:latin typeface="Calibri"/>
-              </a:rPr>
-              <a:t>• Tailings — Critical (TSF count + GISTM consequence class)</a:t>
-            </a:r>
-          </a:p>
-          <a:p>
-            <a:pPr algn="l">
-              <a:lnSpc>
-                <a:spcPct val="118000"/>
-              </a:lnSpc>
-            </a:pPr>
-            <a:r>
-              <a:rPr sz="1100" b="0">
-                <a:solidFill>
-                  <a:srgbClr val="1A1A1A"/>
-                </a:solidFill>
-                <a:latin typeface="Calibri"/>
-              </a:rPr>
-              <a:t>• Soil pollution — Critical (acidic Oxisols + EPI Heavy Metals)</a:t>
-            </a:r>
-          </a:p>
-          <a:p>
-            <a:pPr algn="l">
-              <a:lnSpc>
-                <a:spcPct val="118000"/>
-              </a:lnSpc>
-            </a:pPr>
-            <a:r>
-              <a:rPr sz="1100" b="0">
-                <a:solidFill>
-                  <a:srgbClr val="1A1A1A"/>
-                </a:solidFill>
-                <a:latin typeface="Calibri"/>
-              </a:rPr>
-              <a:t>• Biodiversity loss — Critical (590 IUCN-listed species; high deforestation)</a:t>
-            </a:r>
-          </a:p>
-        </p:txBody>
-      </p:sp>
-      <p:sp>
-        <p:nvSpPr>
-          <p:cNvPr id="8" name="TextBox 7"/>
-          <p:cNvSpPr txBox="1"/>
-          <p:nvPr/>
-        </p:nvSpPr>
-        <p:spPr>
-          <a:xfrm>
-            <a:off x="6400800" y="4892040"/>
-            <a:ext cx="5303520" cy="1554480"/>
-          </a:xfrm>
-          <a:prstGeom prst="rect">
-            <a:avLst/>
-          </a:prstGeom>
-          <a:noFill/>
-        </p:spPr>
-        <p:txBody>
-          <a:bodyPr wrap="square">
-            <a:spAutoFit/>
-          </a:bodyPr>
-          <a:lstStyle/>
-          <a:p>
-            <a:pPr algn="l">
-              <a:lnSpc>
-                <a:spcPct val="118000"/>
-              </a:lnSpc>
-            </a:pPr>
-            <a:r>
-              <a:rPr sz="1100" b="0">
-                <a:solidFill>
-                  <a:srgbClr val="1A1A1A"/>
-                </a:solidFill>
-                <a:latin typeface="Calibri"/>
-              </a:rPr>
-              <a:t>• Each row's drill-down shows raw + normalized scores with source URL</a:t>
-            </a:r>
-          </a:p>
-          <a:p>
-            <a:pPr algn="l">
-              <a:lnSpc>
-                <a:spcPct val="118000"/>
-              </a:lnSpc>
-            </a:pPr>
-            <a:r>
-              <a:rPr sz="1100" b="0">
-                <a:solidFill>
-                  <a:srgbClr val="1A1A1A"/>
-                </a:solidFill>
-                <a:latin typeface="Calibri"/>
-              </a:rPr>
-              <a:t>• Risk Library tab pre-loads SAQ KPIs (e.g. tailings GISTM conformance %, seepage rate) → directly into Glencore's Step 2B questionnaire</a:t>
-            </a:r>
-          </a:p>
-          <a:p>
-            <a:pPr algn="l">
-              <a:lnSpc>
-                <a:spcPct val="118000"/>
-              </a:lnSpc>
-            </a:pPr>
-            <a:r>
-              <a:rPr sz="1100" b="0">
-                <a:solidFill>
-                  <a:srgbClr val="1A1A1A"/>
-                </a:solidFill>
-                <a:latin typeface="Calibri"/>
-              </a:rPr>
-              <a:t>• Likely supplier types ranked: Earth moving · Hazardous chemicals · Waste disposal — narrows the SAQ scope</a:t>
-            </a:r>
-          </a:p>
-        </p:txBody>
-      </p:sp>
-      <p:sp>
-        <p:nvSpPr>
-          <p:cNvPr id="9" name="TextBox 8"/>
-          <p:cNvSpPr txBox="1"/>
-          <p:nvPr/>
-        </p:nvSpPr>
-        <p:spPr>
-          <a:xfrm>
-            <a:off x="457200" y="5989320"/>
-            <a:ext cx="11247120" cy="320040"/>
+              <a:t>What the analyst gets in 10 minutes: ranked risks (Tailings · Soil pollution · Biodiversity → all Critical), KPIs for the SAQ, supplier-type categories, every score auditable to a public dataset URL.</a:t>
+            </a:r>
+          </a:p>
+        </p:txBody>
+      </p:sp>
+      <p:sp>
+        <p:nvSpPr>
+          <p:cNvPr id="22" name="TextBox 21"/>
+          <p:cNvSpPr txBox="1"/>
+          <p:nvPr/>
+        </p:nvSpPr>
+        <p:spPr>
+          <a:xfrm>
+            <a:off x="457200" y="6583680"/>
+            <a:ext cx="11247120" cy="274320"/>
           </a:xfrm>
           <a:prstGeom prst="rect">
             <a:avLst/>
@@ -11328,20 +11951,20 @@
           <a:p>
             <a:pPr algn="l"/>
             <a:r>
-              <a:rPr sz="900" b="0" i="1">
+              <a:rPr sz="800" b="0" i="1">
                 <a:solidFill>
                   <a:srgbClr val="555555"/>
                 </a:solidFill>
                 <a:latin typeface="Calibri"/>
               </a:rPr>
-              <a:t>Sources: USGS MCS 2024; Glencore CAHRA List 2025; ISRIC SoilGrids 2.0; Yale EPI 2024; IUCN Red List API; Global Forest Watch.</a:t>
-            </a:r>
-          </a:p>
-        </p:txBody>
-      </p:sp>
-      <p:sp>
-        <p:nvSpPr>
-          <p:cNvPr id="10" name="TextBox 9"/>
+              <a:t>Sources: USGS MCS 2024 · Glencore CAHRA List 2025 · IEA Critical Minerals Outlook 2024 · ISRIC SoilGrids 2.0 · IUCN Red List · Global Forest Watch · Global Tailings Portal · EU Battery Regulation 2023/1542 · U.S. IRA (Public Law 117–169).</a:t>
+            </a:r>
+          </a:p>
+        </p:txBody>
+      </p:sp>
+      <p:sp>
+        <p:nvSpPr>
+          <p:cNvPr id="23" name="TextBox 22"/>
           <p:cNvSpPr txBox="1"/>
           <p:nvPr/>
         </p:nvSpPr>
@@ -11369,14 +11992,14 @@
                 </a:solidFill>
                 <a:latin typeface="Calibri"/>
               </a:rPr>
-              <a:t>Glencore Environmental Risk Tool — NYU SPS MS Global Affairs</a:t>
-            </a:r>
-          </a:p>
-        </p:txBody>
-      </p:sp>
-      <p:sp>
-        <p:nvSpPr>
-          <p:cNvPr id="11" name="TextBox 10"/>
+              <a:t>Glencore × NYU SPS Center for Global Affairs Consulting Practicum</a:t>
+            </a:r>
+          </a:p>
+        </p:txBody>
+      </p:sp>
+      <p:sp>
+        <p:nvSpPr>
+          <p:cNvPr id="24" name="TextBox 23"/>
           <p:cNvSpPr txBox="1"/>
           <p:nvPr/>
         </p:nvSpPr>
@@ -11404,1944 +12027,7 @@
                 </a:solidFill>
                 <a:latin typeface="Calibri"/>
               </a:rPr>
-              <a:t>7 / 9</a:t>
-            </a:r>
-          </a:p>
-        </p:txBody>
-      </p:sp>
-    </p:spTree>
-  </p:cSld>
-  <p:clrMapOvr>
-    <a:masterClrMapping/>
-  </p:clrMapOvr>
-</p:sld>
-</file>
-
-<file path=ppt/slides/slide8.xml><?xml version="1.0" encoding="utf-8"?>
-<p:sld xmlns:a="http://schemas.openxmlformats.org/drawingml/2006/main" xmlns:p="http://schemas.openxmlformats.org/presentationml/2006/main" xmlns:r="http://schemas.openxmlformats.org/officeDocument/2006/relationships">
-  <p:cSld>
-    <p:spTree>
-      <p:nvGrpSpPr>
-        <p:cNvPr id="1" name=""/>
-        <p:cNvGrpSpPr/>
-        <p:nvPr/>
-      </p:nvGrpSpPr>
-      <p:grpSpPr/>
-      <p:sp>
-        <p:nvSpPr>
-          <p:cNvPr id="2" name="Rectangle 1"/>
-          <p:cNvSpPr/>
-          <p:nvPr/>
-        </p:nvSpPr>
-        <p:spPr>
-          <a:xfrm>
-            <a:off x="0" y="0"/>
-            <a:ext cx="12191695" cy="137160"/>
-          </a:xfrm>
-          <a:prstGeom prst="rect">
-            <a:avLst/>
-          </a:prstGeom>
-          <a:solidFill>
-            <a:srgbClr val="00A9A5"/>
-          </a:solidFill>
-          <a:ln>
-            <a:noFill/>
-          </a:ln>
-          <a:effectLst/>
-        </p:spPr>
-        <p:style>
-          <a:lnRef idx="1">
-            <a:schemeClr val="accent1"/>
-          </a:lnRef>
-          <a:fillRef idx="3">
-            <a:schemeClr val="accent1"/>
-          </a:fillRef>
-          <a:effectRef idx="2">
-            <a:schemeClr val="accent1"/>
-          </a:effectRef>
-          <a:fontRef idx="minor">
-            <a:schemeClr val="lt1"/>
-          </a:fontRef>
-        </p:style>
-        <p:txBody>
-          <a:bodyPr rtlCol="0" anchor="ctr"/>
-          <a:lstStyle/>
-          <a:p>
-            <a:pPr algn="ctr"/>
-          </a:p>
-        </p:txBody>
-      </p:sp>
-      <p:sp>
-        <p:nvSpPr>
-          <p:cNvPr id="3" name="TextBox 2"/>
-          <p:cNvSpPr txBox="1"/>
-          <p:nvPr/>
-        </p:nvSpPr>
-        <p:spPr>
-          <a:xfrm>
-            <a:off x="457200" y="228600"/>
-            <a:ext cx="11247120" cy="548640"/>
-          </a:xfrm>
-          <a:prstGeom prst="rect">
-            <a:avLst/>
-          </a:prstGeom>
-          <a:noFill/>
-        </p:spPr>
-        <p:txBody>
-          <a:bodyPr wrap="square" anchor="t" lIns="45720" rIns="45720">
-            <a:spAutoFit/>
-          </a:bodyPr>
-          <a:lstStyle/>
-          <a:p>
-            <a:pPr algn="l"/>
-            <a:r>
-              <a:rPr sz="2600" b="1" i="0">
-                <a:solidFill>
-                  <a:srgbClr val="005F73"/>
-                </a:solidFill>
-                <a:latin typeface="Calibri"/>
-              </a:rPr>
-              <a:t>Where this fits — Glencore's SCDD Tiers</a:t>
-            </a:r>
-          </a:p>
-        </p:txBody>
-      </p:sp>
-      <p:sp>
-        <p:nvSpPr>
-          <p:cNvPr id="4" name="TextBox 3"/>
-          <p:cNvSpPr txBox="1"/>
-          <p:nvPr/>
-        </p:nvSpPr>
-        <p:spPr>
-          <a:xfrm>
-            <a:off x="457200" y="777240"/>
-            <a:ext cx="11247120" cy="365760"/>
-          </a:xfrm>
-          <a:prstGeom prst="rect">
-            <a:avLst/>
-          </a:prstGeom>
-          <a:noFill/>
-        </p:spPr>
-        <p:txBody>
-          <a:bodyPr wrap="square" anchor="t" lIns="45720" rIns="45720">
-            <a:spAutoFit/>
-          </a:bodyPr>
-          <a:lstStyle/>
-          <a:p>
-            <a:pPr algn="l"/>
-            <a:r>
-              <a:rPr sz="1400" b="0" i="1">
-                <a:solidFill>
-                  <a:srgbClr val="555555"/>
-                </a:solidFill>
-                <a:latin typeface="Calibri"/>
-              </a:rPr>
-              <a:t>Tool automates Tier 1, scopes Tier 2, accelerates Tiers 3–4</a:t>
-            </a:r>
-          </a:p>
-        </p:txBody>
-      </p:sp>
-      <p:sp>
-        <p:nvSpPr>
-          <p:cNvPr id="5" name="Rectangle 4"/>
-          <p:cNvSpPr/>
-          <p:nvPr/>
-        </p:nvSpPr>
-        <p:spPr>
-          <a:xfrm>
-            <a:off x="457200" y="1325880"/>
-            <a:ext cx="1371600" cy="1078992"/>
-          </a:xfrm>
-          <a:prstGeom prst="rect">
-            <a:avLst/>
-          </a:prstGeom>
-          <a:solidFill>
-            <a:srgbClr val="4CAF50"/>
-          </a:solidFill>
-          <a:ln>
-            <a:noFill/>
-          </a:ln>
-          <a:effectLst/>
-        </p:spPr>
-        <p:style>
-          <a:lnRef idx="1">
-            <a:schemeClr val="accent1"/>
-          </a:lnRef>
-          <a:fillRef idx="3">
-            <a:schemeClr val="accent1"/>
-          </a:fillRef>
-          <a:effectRef idx="2">
-            <a:schemeClr val="accent1"/>
-          </a:effectRef>
-          <a:fontRef idx="minor">
-            <a:schemeClr val="lt1"/>
-          </a:fontRef>
-        </p:style>
-        <p:txBody>
-          <a:bodyPr rtlCol="0" anchor="ctr"/>
-          <a:lstStyle/>
-          <a:p>
-            <a:pPr algn="ctr"/>
-          </a:p>
-        </p:txBody>
-      </p:sp>
-      <p:sp>
-        <p:nvSpPr>
-          <p:cNvPr id="6" name="TextBox 5"/>
-          <p:cNvSpPr txBox="1"/>
-          <p:nvPr/>
-        </p:nvSpPr>
-        <p:spPr>
-          <a:xfrm>
-            <a:off x="457200" y="1325880"/>
-            <a:ext cx="1371600" cy="411480"/>
-          </a:xfrm>
-          <a:prstGeom prst="rect">
-            <a:avLst/>
-          </a:prstGeom>
-          <a:noFill/>
-        </p:spPr>
-        <p:txBody>
-          <a:bodyPr wrap="square" anchor="ctr" lIns="45720" rIns="45720">
-            <a:spAutoFit/>
-          </a:bodyPr>
-          <a:lstStyle/>
-          <a:p>
-            <a:pPr algn="ctr"/>
-            <a:r>
-              <a:rPr sz="1800" b="1" i="0">
-                <a:solidFill>
-                  <a:srgbClr val="FFFFFF"/>
-                </a:solidFill>
-                <a:latin typeface="Calibri"/>
-              </a:rPr>
-              <a:t>Tier 1</a:t>
-            </a:r>
-          </a:p>
-        </p:txBody>
-      </p:sp>
-      <p:sp>
-        <p:nvSpPr>
-          <p:cNvPr id="7" name="TextBox 6"/>
-          <p:cNvSpPr txBox="1"/>
-          <p:nvPr/>
-        </p:nvSpPr>
-        <p:spPr>
-          <a:xfrm>
-            <a:off x="457200" y="1783080"/>
-            <a:ext cx="1371600" cy="548640"/>
-          </a:xfrm>
-          <a:prstGeom prst="rect">
-            <a:avLst/>
-          </a:prstGeom>
-          <a:noFill/>
-        </p:spPr>
-        <p:txBody>
-          <a:bodyPr wrap="square" anchor="t" lIns="45720" rIns="45720">
-            <a:spAutoFit/>
-          </a:bodyPr>
-          <a:lstStyle/>
-          <a:p>
-            <a:pPr algn="ctr"/>
-            <a:r>
-              <a:rPr sz="1000" b="0" i="1">
-                <a:solidFill>
-                  <a:srgbClr val="FFFFFF"/>
-                </a:solidFill>
-                <a:latin typeface="Calibri"/>
-              </a:rPr>
-              <a:t>AUTOMATED by tool</a:t>
-            </a:r>
-          </a:p>
-        </p:txBody>
-      </p:sp>
-      <p:sp>
-        <p:nvSpPr>
-          <p:cNvPr id="8" name="Rectangle 7"/>
-          <p:cNvSpPr/>
-          <p:nvPr/>
-        </p:nvSpPr>
-        <p:spPr>
-          <a:xfrm>
-            <a:off x="1874520" y="1325880"/>
-            <a:ext cx="10149840" cy="1078992"/>
-          </a:xfrm>
-          <a:prstGeom prst="rect">
-            <a:avLst/>
-          </a:prstGeom>
-          <a:solidFill>
-            <a:srgbClr val="E0F2F1"/>
-          </a:solidFill>
-          <a:ln>
-            <a:noFill/>
-          </a:ln>
-          <a:effectLst/>
-        </p:spPr>
-        <p:style>
-          <a:lnRef idx="1">
-            <a:schemeClr val="accent1"/>
-          </a:lnRef>
-          <a:fillRef idx="3">
-            <a:schemeClr val="accent1"/>
-          </a:fillRef>
-          <a:effectRef idx="2">
-            <a:schemeClr val="accent1"/>
-          </a:effectRef>
-          <a:fontRef idx="minor">
-            <a:schemeClr val="lt1"/>
-          </a:fontRef>
-        </p:style>
-        <p:txBody>
-          <a:bodyPr rtlCol="0" anchor="ctr"/>
-          <a:lstStyle/>
-          <a:p>
-            <a:pPr algn="ctr"/>
-          </a:p>
-        </p:txBody>
-      </p:sp>
-      <p:sp>
-        <p:nvSpPr>
-          <p:cNvPr id="9" name="TextBox 8"/>
-          <p:cNvSpPr txBox="1"/>
-          <p:nvPr/>
-        </p:nvSpPr>
-        <p:spPr>
-          <a:xfrm>
-            <a:off x="2011680" y="1371600"/>
-            <a:ext cx="7315200" cy="365760"/>
-          </a:xfrm>
-          <a:prstGeom prst="rect">
-            <a:avLst/>
-          </a:prstGeom>
-          <a:noFill/>
-        </p:spPr>
-        <p:txBody>
-          <a:bodyPr wrap="square" anchor="t" lIns="45720" rIns="45720">
-            <a:spAutoFit/>
-          </a:bodyPr>
-          <a:lstStyle/>
-          <a:p>
-            <a:pPr algn="l"/>
-            <a:r>
-              <a:rPr sz="1400" b="1" i="0">
-                <a:solidFill>
-                  <a:srgbClr val="005F73"/>
-                </a:solidFill>
-                <a:latin typeface="Calibri"/>
-              </a:rPr>
-              <a:t>OSDR — desktop research</a:t>
-            </a:r>
-          </a:p>
-        </p:txBody>
-      </p:sp>
-      <p:sp>
-        <p:nvSpPr>
-          <p:cNvPr id="10" name="TextBox 9"/>
-          <p:cNvSpPr txBox="1"/>
-          <p:nvPr/>
-        </p:nvSpPr>
-        <p:spPr>
-          <a:xfrm>
-            <a:off x="8961120" y="1371600"/>
-            <a:ext cx="2834640" cy="365760"/>
-          </a:xfrm>
-          <a:prstGeom prst="rect">
-            <a:avLst/>
-          </a:prstGeom>
-          <a:noFill/>
-        </p:spPr>
-        <p:txBody>
-          <a:bodyPr wrap="square" anchor="t" lIns="45720" rIns="45720">
-            <a:spAutoFit/>
-          </a:bodyPr>
-          <a:lstStyle/>
-          <a:p>
-            <a:pPr algn="r"/>
-            <a:r>
-              <a:rPr sz="1100" b="0" i="1">
-                <a:solidFill>
-                  <a:srgbClr val="555555"/>
-                </a:solidFill>
-                <a:latin typeface="Calibri"/>
-              </a:rPr>
-              <a:t>Step 2A: scoping</a:t>
-            </a:r>
-          </a:p>
-        </p:txBody>
-      </p:sp>
-      <p:sp>
-        <p:nvSpPr>
-          <p:cNvPr id="11" name="TextBox 10"/>
-          <p:cNvSpPr txBox="1"/>
-          <p:nvPr/>
-        </p:nvSpPr>
-        <p:spPr>
-          <a:xfrm>
-            <a:off x="2011680" y="1737360"/>
-            <a:ext cx="9784080" cy="640080"/>
-          </a:xfrm>
-          <a:prstGeom prst="rect">
-            <a:avLst/>
-          </a:prstGeom>
-          <a:noFill/>
-        </p:spPr>
-        <p:txBody>
-          <a:bodyPr wrap="square" anchor="t" lIns="45720" rIns="45720">
-            <a:spAutoFit/>
-          </a:bodyPr>
-          <a:lstStyle/>
-          <a:p>
-            <a:pPr algn="l"/>
-            <a:r>
-              <a:rPr sz="1100" b="0" i="0">
-                <a:solidFill>
-                  <a:srgbClr val="1A1A1A"/>
-                </a:solidFill>
-                <a:latin typeface="Calibri"/>
-              </a:rPr>
-              <a:t>Public data: Aqueduct, EPI, IUCN, WDPA, GTP, SoilGrids, GEM, USGS MRDS</a:t>
-            </a:r>
-          </a:p>
-        </p:txBody>
-      </p:sp>
-      <p:sp>
-        <p:nvSpPr>
-          <p:cNvPr id="12" name="Rectangle 11"/>
-          <p:cNvSpPr/>
-          <p:nvPr/>
-        </p:nvSpPr>
-        <p:spPr>
-          <a:xfrm>
-            <a:off x="457200" y="2478024"/>
-            <a:ext cx="1371600" cy="1078992"/>
-          </a:xfrm>
-          <a:prstGeom prst="rect">
-            <a:avLst/>
-          </a:prstGeom>
-          <a:solidFill>
-            <a:srgbClr val="00A9A5"/>
-          </a:solidFill>
-          <a:ln>
-            <a:noFill/>
-          </a:ln>
-          <a:effectLst/>
-        </p:spPr>
-        <p:style>
-          <a:lnRef idx="1">
-            <a:schemeClr val="accent1"/>
-          </a:lnRef>
-          <a:fillRef idx="3">
-            <a:schemeClr val="accent1"/>
-          </a:fillRef>
-          <a:effectRef idx="2">
-            <a:schemeClr val="accent1"/>
-          </a:effectRef>
-          <a:fontRef idx="minor">
-            <a:schemeClr val="lt1"/>
-          </a:fontRef>
-        </p:style>
-        <p:txBody>
-          <a:bodyPr rtlCol="0" anchor="ctr"/>
-          <a:lstStyle/>
-          <a:p>
-            <a:pPr algn="ctr"/>
-          </a:p>
-        </p:txBody>
-      </p:sp>
-      <p:sp>
-        <p:nvSpPr>
-          <p:cNvPr id="13" name="TextBox 12"/>
-          <p:cNvSpPr txBox="1"/>
-          <p:nvPr/>
-        </p:nvSpPr>
-        <p:spPr>
-          <a:xfrm>
-            <a:off x="457200" y="2478024"/>
-            <a:ext cx="1371600" cy="411480"/>
-          </a:xfrm>
-          <a:prstGeom prst="rect">
-            <a:avLst/>
-          </a:prstGeom>
-          <a:noFill/>
-        </p:spPr>
-        <p:txBody>
-          <a:bodyPr wrap="square" anchor="ctr" lIns="45720" rIns="45720">
-            <a:spAutoFit/>
-          </a:bodyPr>
-          <a:lstStyle/>
-          <a:p>
-            <a:pPr algn="ctr"/>
-            <a:r>
-              <a:rPr sz="1800" b="1" i="0">
-                <a:solidFill>
-                  <a:srgbClr val="FFFFFF"/>
-                </a:solidFill>
-                <a:latin typeface="Calibri"/>
-              </a:rPr>
-              <a:t>Tier 2</a:t>
-            </a:r>
-          </a:p>
-        </p:txBody>
-      </p:sp>
-      <p:sp>
-        <p:nvSpPr>
-          <p:cNvPr id="14" name="TextBox 13"/>
-          <p:cNvSpPr txBox="1"/>
-          <p:nvPr/>
-        </p:nvSpPr>
-        <p:spPr>
-          <a:xfrm>
-            <a:off x="457200" y="2935224"/>
-            <a:ext cx="1371600" cy="548640"/>
-          </a:xfrm>
-          <a:prstGeom prst="rect">
-            <a:avLst/>
-          </a:prstGeom>
-          <a:noFill/>
-        </p:spPr>
-        <p:txBody>
-          <a:bodyPr wrap="square" anchor="t" lIns="45720" rIns="45720">
-            <a:spAutoFit/>
-          </a:bodyPr>
-          <a:lstStyle/>
-          <a:p>
-            <a:pPr algn="ctr"/>
-            <a:r>
-              <a:rPr sz="1000" b="0" i="1">
-                <a:solidFill>
-                  <a:srgbClr val="FFFFFF"/>
-                </a:solidFill>
-                <a:latin typeface="Calibri"/>
-              </a:rPr>
-              <a:t>Tool scopes the SAQ</a:t>
-            </a:r>
-          </a:p>
-        </p:txBody>
-      </p:sp>
-      <p:sp>
-        <p:nvSpPr>
-          <p:cNvPr id="15" name="Rectangle 14"/>
-          <p:cNvSpPr/>
-          <p:nvPr/>
-        </p:nvSpPr>
-        <p:spPr>
-          <a:xfrm>
-            <a:off x="1874520" y="2478024"/>
-            <a:ext cx="10149840" cy="1078992"/>
-          </a:xfrm>
-          <a:prstGeom prst="rect">
-            <a:avLst/>
-          </a:prstGeom>
-          <a:solidFill>
-            <a:srgbClr val="FFFFFF"/>
-          </a:solidFill>
-          <a:ln>
-            <a:noFill/>
-          </a:ln>
-          <a:effectLst/>
-        </p:spPr>
-        <p:style>
-          <a:lnRef idx="1">
-            <a:schemeClr val="accent1"/>
-          </a:lnRef>
-          <a:fillRef idx="3">
-            <a:schemeClr val="accent1"/>
-          </a:fillRef>
-          <a:effectRef idx="2">
-            <a:schemeClr val="accent1"/>
-          </a:effectRef>
-          <a:fontRef idx="minor">
-            <a:schemeClr val="lt1"/>
-          </a:fontRef>
-        </p:style>
-        <p:txBody>
-          <a:bodyPr rtlCol="0" anchor="ctr"/>
-          <a:lstStyle/>
-          <a:p>
-            <a:pPr algn="ctr"/>
-          </a:p>
-        </p:txBody>
-      </p:sp>
-      <p:sp>
-        <p:nvSpPr>
-          <p:cNvPr id="16" name="TextBox 15"/>
-          <p:cNvSpPr txBox="1"/>
-          <p:nvPr/>
-        </p:nvSpPr>
-        <p:spPr>
-          <a:xfrm>
-            <a:off x="2011680" y="2523744"/>
-            <a:ext cx="7315200" cy="365760"/>
-          </a:xfrm>
-          <a:prstGeom prst="rect">
-            <a:avLst/>
-          </a:prstGeom>
-          <a:noFill/>
-        </p:spPr>
-        <p:txBody>
-          <a:bodyPr wrap="square" anchor="t" lIns="45720" rIns="45720">
-            <a:spAutoFit/>
-          </a:bodyPr>
-          <a:lstStyle/>
-          <a:p>
-            <a:pPr algn="l"/>
-            <a:r>
-              <a:rPr sz="1400" b="1" i="0">
-                <a:solidFill>
-                  <a:srgbClr val="005F73"/>
-                </a:solidFill>
-                <a:latin typeface="Calibri"/>
-              </a:rPr>
-              <a:t>SAQ — Supplier Questionnaire</a:t>
-            </a:r>
-          </a:p>
-        </p:txBody>
-      </p:sp>
-      <p:sp>
-        <p:nvSpPr>
-          <p:cNvPr id="17" name="TextBox 16"/>
-          <p:cNvSpPr txBox="1"/>
-          <p:nvPr/>
-        </p:nvSpPr>
-        <p:spPr>
-          <a:xfrm>
-            <a:off x="8961120" y="2523744"/>
-            <a:ext cx="2834640" cy="365760"/>
-          </a:xfrm>
-          <a:prstGeom prst="rect">
-            <a:avLst/>
-          </a:prstGeom>
-          <a:noFill/>
-        </p:spPr>
-        <p:txBody>
-          <a:bodyPr wrap="square" anchor="t" lIns="45720" rIns="45720">
-            <a:spAutoFit/>
-          </a:bodyPr>
-          <a:lstStyle/>
-          <a:p>
-            <a:pPr algn="r"/>
-            <a:r>
-              <a:rPr sz="1100" b="0" i="1">
-                <a:solidFill>
-                  <a:srgbClr val="555555"/>
-                </a:solidFill>
-                <a:latin typeface="Calibri"/>
-              </a:rPr>
-              <a:t>Step 2B &amp; 2C</a:t>
-            </a:r>
-          </a:p>
-        </p:txBody>
-      </p:sp>
-      <p:sp>
-        <p:nvSpPr>
-          <p:cNvPr id="18" name="TextBox 17"/>
-          <p:cNvSpPr txBox="1"/>
-          <p:nvPr/>
-        </p:nvSpPr>
-        <p:spPr>
-          <a:xfrm>
-            <a:off x="2011680" y="2889504"/>
-            <a:ext cx="9784080" cy="640080"/>
-          </a:xfrm>
-          <a:prstGeom prst="rect">
-            <a:avLst/>
-          </a:prstGeom>
-          <a:noFill/>
-        </p:spPr>
-        <p:txBody>
-          <a:bodyPr wrap="square" anchor="t" lIns="45720" rIns="45720">
-            <a:spAutoFit/>
-          </a:bodyPr>
-          <a:lstStyle/>
-          <a:p>
-            <a:pPr algn="l"/>
-            <a:r>
-              <a:rPr sz="1100" b="0" i="0">
-                <a:solidFill>
-                  <a:srgbClr val="1A1A1A"/>
-                </a:solidFill>
-                <a:latin typeface="Calibri"/>
-              </a:rPr>
-              <a:t>Tool's Risk Library + KPI list → directly into the SAQ template</a:t>
-            </a:r>
-          </a:p>
-        </p:txBody>
-      </p:sp>
-      <p:sp>
-        <p:nvSpPr>
-          <p:cNvPr id="19" name="Rectangle 18"/>
-          <p:cNvSpPr/>
-          <p:nvPr/>
-        </p:nvSpPr>
-        <p:spPr>
-          <a:xfrm>
-            <a:off x="457200" y="3630168"/>
-            <a:ext cx="1371600" cy="1078992"/>
-          </a:xfrm>
-          <a:prstGeom prst="rect">
-            <a:avLst/>
-          </a:prstGeom>
-          <a:solidFill>
-            <a:srgbClr val="FF9800"/>
-          </a:solidFill>
-          <a:ln>
-            <a:noFill/>
-          </a:ln>
-          <a:effectLst/>
-        </p:spPr>
-        <p:style>
-          <a:lnRef idx="1">
-            <a:schemeClr val="accent1"/>
-          </a:lnRef>
-          <a:fillRef idx="3">
-            <a:schemeClr val="accent1"/>
-          </a:fillRef>
-          <a:effectRef idx="2">
-            <a:schemeClr val="accent1"/>
-          </a:effectRef>
-          <a:fontRef idx="minor">
-            <a:schemeClr val="lt1"/>
-          </a:fontRef>
-        </p:style>
-        <p:txBody>
-          <a:bodyPr rtlCol="0" anchor="ctr"/>
-          <a:lstStyle/>
-          <a:p>
-            <a:pPr algn="ctr"/>
-          </a:p>
-        </p:txBody>
-      </p:sp>
-      <p:sp>
-        <p:nvSpPr>
-          <p:cNvPr id="20" name="TextBox 19"/>
-          <p:cNvSpPr txBox="1"/>
-          <p:nvPr/>
-        </p:nvSpPr>
-        <p:spPr>
-          <a:xfrm>
-            <a:off x="457200" y="3630168"/>
-            <a:ext cx="1371600" cy="411480"/>
-          </a:xfrm>
-          <a:prstGeom prst="rect">
-            <a:avLst/>
-          </a:prstGeom>
-          <a:noFill/>
-        </p:spPr>
-        <p:txBody>
-          <a:bodyPr wrap="square" anchor="ctr" lIns="45720" rIns="45720">
-            <a:spAutoFit/>
-          </a:bodyPr>
-          <a:lstStyle/>
-          <a:p>
-            <a:pPr algn="ctr"/>
-            <a:r>
-              <a:rPr sz="1800" b="1" i="0">
-                <a:solidFill>
-                  <a:srgbClr val="FFFFFF"/>
-                </a:solidFill>
-                <a:latin typeface="Calibri"/>
-              </a:rPr>
-              <a:t>Tier 3</a:t>
-            </a:r>
-          </a:p>
-        </p:txBody>
-      </p:sp>
-      <p:sp>
-        <p:nvSpPr>
-          <p:cNvPr id="21" name="TextBox 20"/>
-          <p:cNvSpPr txBox="1"/>
-          <p:nvPr/>
-        </p:nvSpPr>
-        <p:spPr>
-          <a:xfrm>
-            <a:off x="457200" y="4087368"/>
-            <a:ext cx="1371600" cy="548640"/>
-          </a:xfrm>
-          <a:prstGeom prst="rect">
-            <a:avLst/>
-          </a:prstGeom>
-          <a:noFill/>
-        </p:spPr>
-        <p:txBody>
-          <a:bodyPr wrap="square" anchor="t" lIns="45720" rIns="45720">
-            <a:spAutoFit/>
-          </a:bodyPr>
-          <a:lstStyle/>
-          <a:p>
-            <a:pPr algn="ctr"/>
-            <a:r>
-              <a:rPr sz="1000" b="0" i="1">
-                <a:solidFill>
-                  <a:srgbClr val="FFFFFF"/>
-                </a:solidFill>
-                <a:latin typeface="Calibri"/>
-              </a:rPr>
-              <a:t>Tool ranks priorities</a:t>
-            </a:r>
-          </a:p>
-        </p:txBody>
-      </p:sp>
-      <p:sp>
-        <p:nvSpPr>
-          <p:cNvPr id="22" name="Rectangle 21"/>
-          <p:cNvSpPr/>
-          <p:nvPr/>
-        </p:nvSpPr>
-        <p:spPr>
-          <a:xfrm>
-            <a:off x="1874520" y="3630168"/>
-            <a:ext cx="10149840" cy="1078992"/>
-          </a:xfrm>
-          <a:prstGeom prst="rect">
-            <a:avLst/>
-          </a:prstGeom>
-          <a:solidFill>
-            <a:srgbClr val="E0F2F1"/>
-          </a:solidFill>
-          <a:ln>
-            <a:noFill/>
-          </a:ln>
-          <a:effectLst/>
-        </p:spPr>
-        <p:style>
-          <a:lnRef idx="1">
-            <a:schemeClr val="accent1"/>
-          </a:lnRef>
-          <a:fillRef idx="3">
-            <a:schemeClr val="accent1"/>
-          </a:fillRef>
-          <a:effectRef idx="2">
-            <a:schemeClr val="accent1"/>
-          </a:effectRef>
-          <a:fontRef idx="minor">
-            <a:schemeClr val="lt1"/>
-          </a:fontRef>
-        </p:style>
-        <p:txBody>
-          <a:bodyPr rtlCol="0" anchor="ctr"/>
-          <a:lstStyle/>
-          <a:p>
-            <a:pPr algn="ctr"/>
-          </a:p>
-        </p:txBody>
-      </p:sp>
-      <p:sp>
-        <p:nvSpPr>
-          <p:cNvPr id="23" name="TextBox 22"/>
-          <p:cNvSpPr txBox="1"/>
-          <p:nvPr/>
-        </p:nvSpPr>
-        <p:spPr>
-          <a:xfrm>
-            <a:off x="2011680" y="3675888"/>
-            <a:ext cx="7315200" cy="365760"/>
-          </a:xfrm>
-          <a:prstGeom prst="rect">
-            <a:avLst/>
-          </a:prstGeom>
-          <a:noFill/>
-        </p:spPr>
-        <p:txBody>
-          <a:bodyPr wrap="square" anchor="t" lIns="45720" rIns="45720">
-            <a:spAutoFit/>
-          </a:bodyPr>
-          <a:lstStyle/>
-          <a:p>
-            <a:pPr algn="l"/>
-            <a:r>
-              <a:rPr sz="1400" b="1" i="0">
-                <a:solidFill>
-                  <a:srgbClr val="005F73"/>
-                </a:solidFill>
-                <a:latin typeface="Calibri"/>
-              </a:rPr>
-              <a:t>Onsite / OGA — On-the-ground assessment</a:t>
-            </a:r>
-          </a:p>
-        </p:txBody>
-      </p:sp>
-      <p:sp>
-        <p:nvSpPr>
-          <p:cNvPr id="24" name="TextBox 23"/>
-          <p:cNvSpPr txBox="1"/>
-          <p:nvPr/>
-        </p:nvSpPr>
-        <p:spPr>
-          <a:xfrm>
-            <a:off x="8961120" y="3675888"/>
-            <a:ext cx="2834640" cy="365760"/>
-          </a:xfrm>
-          <a:prstGeom prst="rect">
-            <a:avLst/>
-          </a:prstGeom>
-          <a:noFill/>
-        </p:spPr>
-        <p:txBody>
-          <a:bodyPr wrap="square" anchor="t" lIns="45720" rIns="45720">
-            <a:spAutoFit/>
-          </a:bodyPr>
-          <a:lstStyle/>
-          <a:p>
-            <a:pPr algn="r"/>
-            <a:r>
-              <a:rPr sz="1100" b="0" i="1">
-                <a:solidFill>
-                  <a:srgbClr val="555555"/>
-                </a:solidFill>
-                <a:latin typeface="Calibri"/>
-              </a:rPr>
-              <a:t>Step 3.1.5</a:t>
-            </a:r>
-          </a:p>
-        </p:txBody>
-      </p:sp>
-      <p:sp>
-        <p:nvSpPr>
-          <p:cNvPr id="25" name="TextBox 24"/>
-          <p:cNvSpPr txBox="1"/>
-          <p:nvPr/>
-        </p:nvSpPr>
-        <p:spPr>
-          <a:xfrm>
-            <a:off x="2011680" y="4041648"/>
-            <a:ext cx="9784080" cy="640080"/>
-          </a:xfrm>
-          <a:prstGeom prst="rect">
-            <a:avLst/>
-          </a:prstGeom>
-          <a:noFill/>
-        </p:spPr>
-        <p:txBody>
-          <a:bodyPr wrap="square" anchor="t" lIns="45720" rIns="45720">
-            <a:spAutoFit/>
-          </a:bodyPr>
-          <a:lstStyle/>
-          <a:p>
-            <a:pPr algn="l"/>
-            <a:r>
-              <a:rPr sz="1100" b="0" i="0">
-                <a:solidFill>
-                  <a:srgbClr val="1A1A1A"/>
-                </a:solidFill>
-                <a:latin typeface="Calibri"/>
-              </a:rPr>
-              <a:t>Critical-bucket rows define the onsite agenda; sampling priorities</a:t>
-            </a:r>
-          </a:p>
-        </p:txBody>
-      </p:sp>
-      <p:sp>
-        <p:nvSpPr>
-          <p:cNvPr id="26" name="Rectangle 25"/>
-          <p:cNvSpPr/>
-          <p:nvPr/>
-        </p:nvSpPr>
-        <p:spPr>
-          <a:xfrm>
-            <a:off x="457200" y="4782312"/>
-            <a:ext cx="1371600" cy="1078992"/>
-          </a:xfrm>
-          <a:prstGeom prst="rect">
-            <a:avLst/>
-          </a:prstGeom>
-          <a:solidFill>
-            <a:srgbClr val="E53935"/>
-          </a:solidFill>
-          <a:ln>
-            <a:noFill/>
-          </a:ln>
-          <a:effectLst/>
-        </p:spPr>
-        <p:style>
-          <a:lnRef idx="1">
-            <a:schemeClr val="accent1"/>
-          </a:lnRef>
-          <a:fillRef idx="3">
-            <a:schemeClr val="accent1"/>
-          </a:fillRef>
-          <a:effectRef idx="2">
-            <a:schemeClr val="accent1"/>
-          </a:effectRef>
-          <a:fontRef idx="minor">
-            <a:schemeClr val="lt1"/>
-          </a:fontRef>
-        </p:style>
-        <p:txBody>
-          <a:bodyPr rtlCol="0" anchor="ctr"/>
-          <a:lstStyle/>
-          <a:p>
-            <a:pPr algn="ctr"/>
-          </a:p>
-        </p:txBody>
-      </p:sp>
-      <p:sp>
-        <p:nvSpPr>
-          <p:cNvPr id="27" name="TextBox 26"/>
-          <p:cNvSpPr txBox="1"/>
-          <p:nvPr/>
-        </p:nvSpPr>
-        <p:spPr>
-          <a:xfrm>
-            <a:off x="457200" y="4782312"/>
-            <a:ext cx="1371600" cy="411480"/>
-          </a:xfrm>
-          <a:prstGeom prst="rect">
-            <a:avLst/>
-          </a:prstGeom>
-          <a:noFill/>
-        </p:spPr>
-        <p:txBody>
-          <a:bodyPr wrap="square" anchor="ctr" lIns="45720" rIns="45720">
-            <a:spAutoFit/>
-          </a:bodyPr>
-          <a:lstStyle/>
-          <a:p>
-            <a:pPr algn="ctr"/>
-            <a:r>
-              <a:rPr sz="1800" b="1" i="0">
-                <a:solidFill>
-                  <a:srgbClr val="FFFFFF"/>
-                </a:solidFill>
-                <a:latin typeface="Calibri"/>
-              </a:rPr>
-              <a:t>Tier 4</a:t>
-            </a:r>
-          </a:p>
-        </p:txBody>
-      </p:sp>
-      <p:sp>
-        <p:nvSpPr>
-          <p:cNvPr id="28" name="TextBox 27"/>
-          <p:cNvSpPr txBox="1"/>
-          <p:nvPr/>
-        </p:nvSpPr>
-        <p:spPr>
-          <a:xfrm>
-            <a:off x="457200" y="5239512"/>
-            <a:ext cx="1371600" cy="548640"/>
-          </a:xfrm>
-          <a:prstGeom prst="rect">
-            <a:avLst/>
-          </a:prstGeom>
-          <a:noFill/>
-        </p:spPr>
-        <p:txBody>
-          <a:bodyPr wrap="square" anchor="t" lIns="45720" rIns="45720">
-            <a:spAutoFit/>
-          </a:bodyPr>
-          <a:lstStyle/>
-          <a:p>
-            <a:pPr algn="ctr"/>
-            <a:r>
-              <a:rPr sz="1000" b="0" i="1">
-                <a:solidFill>
-                  <a:srgbClr val="FFFFFF"/>
-                </a:solidFill>
-                <a:latin typeface="Calibri"/>
-              </a:rPr>
-              <a:t>Tool identifies milestones</a:t>
-            </a:r>
-          </a:p>
-        </p:txBody>
-      </p:sp>
-      <p:sp>
-        <p:nvSpPr>
-          <p:cNvPr id="29" name="Rectangle 28"/>
-          <p:cNvSpPr/>
-          <p:nvPr/>
-        </p:nvSpPr>
-        <p:spPr>
-          <a:xfrm>
-            <a:off x="1874520" y="4782312"/>
-            <a:ext cx="10149840" cy="1078992"/>
-          </a:xfrm>
-          <a:prstGeom prst="rect">
-            <a:avLst/>
-          </a:prstGeom>
-          <a:solidFill>
-            <a:srgbClr val="FFFFFF"/>
-          </a:solidFill>
-          <a:ln>
-            <a:noFill/>
-          </a:ln>
-          <a:effectLst/>
-        </p:spPr>
-        <p:style>
-          <a:lnRef idx="1">
-            <a:schemeClr val="accent1"/>
-          </a:lnRef>
-          <a:fillRef idx="3">
-            <a:schemeClr val="accent1"/>
-          </a:fillRef>
-          <a:effectRef idx="2">
-            <a:schemeClr val="accent1"/>
-          </a:effectRef>
-          <a:fontRef idx="minor">
-            <a:schemeClr val="lt1"/>
-          </a:fontRef>
-        </p:style>
-        <p:txBody>
-          <a:bodyPr rtlCol="0" anchor="ctr"/>
-          <a:lstStyle/>
-          <a:p>
-            <a:pPr algn="ctr"/>
-          </a:p>
-        </p:txBody>
-      </p:sp>
-      <p:sp>
-        <p:nvSpPr>
-          <p:cNvPr id="30" name="TextBox 29"/>
-          <p:cNvSpPr txBox="1"/>
-          <p:nvPr/>
-        </p:nvSpPr>
-        <p:spPr>
-          <a:xfrm>
-            <a:off x="2011680" y="4828032"/>
-            <a:ext cx="7315200" cy="365760"/>
-          </a:xfrm>
-          <a:prstGeom prst="rect">
-            <a:avLst/>
-          </a:prstGeom>
-          <a:noFill/>
-        </p:spPr>
-        <p:txBody>
-          <a:bodyPr wrap="square" anchor="t" lIns="45720" rIns="45720">
-            <a:spAutoFit/>
-          </a:bodyPr>
-          <a:lstStyle/>
-          <a:p>
-            <a:pPr algn="l"/>
-            <a:r>
-              <a:rPr sz="1400" b="1" i="0">
-                <a:solidFill>
-                  <a:srgbClr val="005F73"/>
-                </a:solidFill>
-                <a:latin typeface="Calibri"/>
-              </a:rPr>
-              <a:t>CAP — Corrective Action Plan</a:t>
-            </a:r>
-          </a:p>
-        </p:txBody>
-      </p:sp>
-      <p:sp>
-        <p:nvSpPr>
-          <p:cNvPr id="31" name="TextBox 30"/>
-          <p:cNvSpPr txBox="1"/>
-          <p:nvPr/>
-        </p:nvSpPr>
-        <p:spPr>
-          <a:xfrm>
-            <a:off x="8961120" y="4828032"/>
-            <a:ext cx="2834640" cy="365760"/>
-          </a:xfrm>
-          <a:prstGeom prst="rect">
-            <a:avLst/>
-          </a:prstGeom>
-          <a:noFill/>
-        </p:spPr>
-        <p:txBody>
-          <a:bodyPr wrap="square" anchor="t" lIns="45720" rIns="45720">
-            <a:spAutoFit/>
-          </a:bodyPr>
-          <a:lstStyle/>
-          <a:p>
-            <a:pPr algn="r"/>
-            <a:r>
-              <a:rPr sz="1100" b="0" i="1">
-                <a:solidFill>
-                  <a:srgbClr val="555555"/>
-                </a:solidFill>
-                <a:latin typeface="Calibri"/>
-              </a:rPr>
-              <a:t>Step 3.1.7</a:t>
-            </a:r>
-          </a:p>
-        </p:txBody>
-      </p:sp>
-      <p:sp>
-        <p:nvSpPr>
-          <p:cNvPr id="32" name="TextBox 31"/>
-          <p:cNvSpPr txBox="1"/>
-          <p:nvPr/>
-        </p:nvSpPr>
-        <p:spPr>
-          <a:xfrm>
-            <a:off x="2011680" y="5193792"/>
-            <a:ext cx="9784080" cy="640080"/>
-          </a:xfrm>
-          <a:prstGeom prst="rect">
-            <a:avLst/>
-          </a:prstGeom>
-          <a:noFill/>
-        </p:spPr>
-        <p:txBody>
-          <a:bodyPr wrap="square" anchor="t" lIns="45720" rIns="45720">
-            <a:spAutoFit/>
-          </a:bodyPr>
-          <a:lstStyle/>
-          <a:p>
-            <a:pPr algn="l"/>
-            <a:r>
-              <a:rPr sz="1100" b="0" i="0">
-                <a:solidFill>
-                  <a:srgbClr val="1A1A1A"/>
-                </a:solidFill>
-                <a:latin typeface="Calibri"/>
-              </a:rPr>
-              <a:t>KPIs become CAP milestones; ongoing monitoring tracks improvement</a:t>
-            </a:r>
-          </a:p>
-        </p:txBody>
-      </p:sp>
-      <p:sp>
-        <p:nvSpPr>
-          <p:cNvPr id="33" name="TextBox 32"/>
-          <p:cNvSpPr txBox="1"/>
-          <p:nvPr/>
-        </p:nvSpPr>
-        <p:spPr>
-          <a:xfrm>
-            <a:off x="457200" y="5989320"/>
-            <a:ext cx="11247120" cy="320040"/>
-          </a:xfrm>
-          <a:prstGeom prst="rect">
-            <a:avLst/>
-          </a:prstGeom>
-          <a:noFill/>
-        </p:spPr>
-        <p:txBody>
-          <a:bodyPr wrap="square" anchor="t" lIns="45720" rIns="45720">
-            <a:spAutoFit/>
-          </a:bodyPr>
-          <a:lstStyle/>
-          <a:p>
-            <a:pPr algn="l"/>
-            <a:r>
-              <a:rPr sz="900" b="0" i="1">
-                <a:solidFill>
-                  <a:srgbClr val="555555"/>
-                </a:solidFill>
-                <a:latin typeface="Calibri"/>
-              </a:rPr>
-              <a:t>Sources: Glencore SCDD Procedure for Metals &amp; Minerals (2024); OECD DDG (3rd ed.); RMI Supply Chain DD Plus Module (April 2025).</a:t>
-            </a:r>
-          </a:p>
-        </p:txBody>
-      </p:sp>
-      <p:sp>
-        <p:nvSpPr>
-          <p:cNvPr id="34" name="TextBox 33"/>
-          <p:cNvSpPr txBox="1"/>
-          <p:nvPr/>
-        </p:nvSpPr>
-        <p:spPr>
-          <a:xfrm>
-            <a:off x="457200" y="6446520"/>
-            <a:ext cx="7315200" cy="320040"/>
-          </a:xfrm>
-          <a:prstGeom prst="rect">
-            <a:avLst/>
-          </a:prstGeom>
-          <a:noFill/>
-        </p:spPr>
-        <p:txBody>
-          <a:bodyPr wrap="square" anchor="t" lIns="45720" rIns="45720">
-            <a:spAutoFit/>
-          </a:bodyPr>
-          <a:lstStyle/>
-          <a:p>
-            <a:pPr algn="l"/>
-            <a:r>
-              <a:rPr sz="900" b="0" i="1">
-                <a:solidFill>
-                  <a:srgbClr val="555555"/>
-                </a:solidFill>
-                <a:latin typeface="Calibri"/>
-              </a:rPr>
-              <a:t>Glencore Environmental Risk Tool — NYU SPS MS Global Affairs</a:t>
-            </a:r>
-          </a:p>
-        </p:txBody>
-      </p:sp>
-      <p:sp>
-        <p:nvSpPr>
-          <p:cNvPr id="35" name="TextBox 34"/>
-          <p:cNvSpPr txBox="1"/>
-          <p:nvPr/>
-        </p:nvSpPr>
-        <p:spPr>
-          <a:xfrm>
-            <a:off x="10515600" y="6446520"/>
-            <a:ext cx="1188720" cy="320040"/>
-          </a:xfrm>
-          <a:prstGeom prst="rect">
-            <a:avLst/>
-          </a:prstGeom>
-          <a:noFill/>
-        </p:spPr>
-        <p:txBody>
-          <a:bodyPr wrap="square" anchor="t" lIns="45720" rIns="45720">
-            <a:spAutoFit/>
-          </a:bodyPr>
-          <a:lstStyle/>
-          <a:p>
-            <a:pPr algn="r"/>
-            <a:r>
-              <a:rPr sz="900" b="0" i="0">
-                <a:solidFill>
-                  <a:srgbClr val="555555"/>
-                </a:solidFill>
-                <a:latin typeface="Calibri"/>
-              </a:rPr>
-              <a:t>8 / 9</a:t>
-            </a:r>
-          </a:p>
-        </p:txBody>
-      </p:sp>
-    </p:spTree>
-  </p:cSld>
-  <p:clrMapOvr>
-    <a:masterClrMapping/>
-  </p:clrMapOvr>
-</p:sld>
-</file>
-
-<file path=ppt/slides/slide9.xml><?xml version="1.0" encoding="utf-8"?>
-<p:sld xmlns:a="http://schemas.openxmlformats.org/drawingml/2006/main" xmlns:p="http://schemas.openxmlformats.org/presentationml/2006/main" xmlns:r="http://schemas.openxmlformats.org/officeDocument/2006/relationships">
-  <p:cSld>
-    <p:spTree>
-      <p:nvGrpSpPr>
-        <p:cNvPr id="1" name=""/>
-        <p:cNvGrpSpPr/>
-        <p:nvPr/>
-      </p:nvGrpSpPr>
-      <p:grpSpPr/>
-      <p:sp>
-        <p:nvSpPr>
-          <p:cNvPr id="2" name="Rectangle 1"/>
-          <p:cNvSpPr/>
-          <p:nvPr/>
-        </p:nvSpPr>
-        <p:spPr>
-          <a:xfrm>
-            <a:off x="0" y="0"/>
-            <a:ext cx="12191695" cy="137160"/>
-          </a:xfrm>
-          <a:prstGeom prst="rect">
-            <a:avLst/>
-          </a:prstGeom>
-          <a:solidFill>
-            <a:srgbClr val="00A9A5"/>
-          </a:solidFill>
-          <a:ln>
-            <a:noFill/>
-          </a:ln>
-          <a:effectLst/>
-        </p:spPr>
-        <p:style>
-          <a:lnRef idx="1">
-            <a:schemeClr val="accent1"/>
-          </a:lnRef>
-          <a:fillRef idx="3">
-            <a:schemeClr val="accent1"/>
-          </a:fillRef>
-          <a:effectRef idx="2">
-            <a:schemeClr val="accent1"/>
-          </a:effectRef>
-          <a:fontRef idx="minor">
-            <a:schemeClr val="lt1"/>
-          </a:fontRef>
-        </p:style>
-        <p:txBody>
-          <a:bodyPr rtlCol="0" anchor="ctr"/>
-          <a:lstStyle/>
-          <a:p>
-            <a:pPr algn="ctr"/>
-          </a:p>
-        </p:txBody>
-      </p:sp>
-      <p:sp>
-        <p:nvSpPr>
-          <p:cNvPr id="3" name="TextBox 2"/>
-          <p:cNvSpPr txBox="1"/>
-          <p:nvPr/>
-        </p:nvSpPr>
-        <p:spPr>
-          <a:xfrm>
-            <a:off x="457200" y="228600"/>
-            <a:ext cx="11247120" cy="548640"/>
-          </a:xfrm>
-          <a:prstGeom prst="rect">
-            <a:avLst/>
-          </a:prstGeom>
-          <a:noFill/>
-        </p:spPr>
-        <p:txBody>
-          <a:bodyPr wrap="square" anchor="t" lIns="45720" rIns="45720">
-            <a:spAutoFit/>
-          </a:bodyPr>
-          <a:lstStyle/>
-          <a:p>
-            <a:pPr algn="l"/>
-            <a:r>
-              <a:rPr sz="2600" b="1" i="0">
-                <a:solidFill>
-                  <a:srgbClr val="005F73"/>
-                </a:solidFill>
-                <a:latin typeface="Calibri"/>
-              </a:rPr>
-              <a:t>Status &amp; roadmap</a:t>
-            </a:r>
-          </a:p>
-        </p:txBody>
-      </p:sp>
-      <p:sp>
-        <p:nvSpPr>
-          <p:cNvPr id="4" name="TextBox 3"/>
-          <p:cNvSpPr txBox="1"/>
-          <p:nvPr/>
-        </p:nvSpPr>
-        <p:spPr>
-          <a:xfrm>
-            <a:off x="457200" y="777240"/>
-            <a:ext cx="11247120" cy="365760"/>
-          </a:xfrm>
-          <a:prstGeom prst="rect">
-            <a:avLst/>
-          </a:prstGeom>
-          <a:noFill/>
-        </p:spPr>
-        <p:txBody>
-          <a:bodyPr wrap="square" anchor="t" lIns="45720" rIns="45720">
-            <a:spAutoFit/>
-          </a:bodyPr>
-          <a:lstStyle/>
-          <a:p>
-            <a:pPr algn="l"/>
-            <a:r>
-              <a:rPr sz="1400" b="0" i="1">
-                <a:solidFill>
-                  <a:srgbClr val="555555"/>
-                </a:solidFill>
-                <a:latin typeface="Calibri"/>
-              </a:rPr>
-              <a:t>Handover-ready · public repo · permanent Streamlit URL</a:t>
-            </a:r>
-          </a:p>
-        </p:txBody>
-      </p:sp>
-      <p:sp>
-        <p:nvSpPr>
-          <p:cNvPr id="5" name="TextBox 4"/>
-          <p:cNvSpPr txBox="1"/>
-          <p:nvPr/>
-        </p:nvSpPr>
-        <p:spPr>
-          <a:xfrm>
-            <a:off x="457200" y="1371600"/>
-            <a:ext cx="5486400" cy="365760"/>
-          </a:xfrm>
-          <a:prstGeom prst="rect">
-            <a:avLst/>
-          </a:prstGeom>
-          <a:noFill/>
-        </p:spPr>
-        <p:txBody>
-          <a:bodyPr wrap="square" anchor="t" lIns="45720" rIns="45720">
-            <a:spAutoFit/>
-          </a:bodyPr>
-          <a:lstStyle/>
-          <a:p>
-            <a:pPr algn="l"/>
-            <a:r>
-              <a:rPr sz="1500" b="1" i="0">
-                <a:solidFill>
-                  <a:srgbClr val="005F73"/>
-                </a:solidFill>
-                <a:latin typeface="Calibri"/>
-              </a:rPr>
-              <a:t>What's shipping today</a:t>
-            </a:r>
-          </a:p>
-        </p:txBody>
-      </p:sp>
-      <p:sp>
-        <p:nvSpPr>
-          <p:cNvPr id="6" name="TextBox 5"/>
-          <p:cNvSpPr txBox="1"/>
-          <p:nvPr/>
-        </p:nvSpPr>
-        <p:spPr>
-          <a:xfrm>
-            <a:off x="457200" y="1783080"/>
-            <a:ext cx="5486400" cy="2377440"/>
-          </a:xfrm>
-          <a:prstGeom prst="rect">
-            <a:avLst/>
-          </a:prstGeom>
-          <a:noFill/>
-        </p:spPr>
-        <p:txBody>
-          <a:bodyPr wrap="square">
-            <a:spAutoFit/>
-          </a:bodyPr>
-          <a:lstStyle/>
-          <a:p>
-            <a:pPr algn="l">
-              <a:lnSpc>
-                <a:spcPct val="118000"/>
-              </a:lnSpc>
-            </a:pPr>
-            <a:r>
-              <a:rPr sz="1100" b="0">
-                <a:solidFill>
-                  <a:srgbClr val="1A1A1A"/>
-                </a:solidFill>
-                <a:latin typeface="Calibri"/>
-              </a:rPr>
-              <a:t>• Public repo — github.com/mnmarkovitz/glencore_enviro_risk_tool</a:t>
-            </a:r>
-          </a:p>
-          <a:p>
-            <a:pPr algn="l">
-              <a:lnSpc>
-                <a:spcPct val="118000"/>
-              </a:lnSpc>
-            </a:pPr>
-            <a:r>
-              <a:rPr sz="1100" b="0">
-                <a:solidFill>
-                  <a:srgbClr val="1A1A1A"/>
-                </a:solidFill>
-                <a:latin typeface="Calibri"/>
-              </a:rPr>
-              <a:t>• Live Streamlit app — public URL via Streamlit Community Cloud</a:t>
-            </a:r>
-          </a:p>
-          <a:p>
-            <a:pPr algn="l">
-              <a:lnSpc>
-                <a:spcPct val="118000"/>
-              </a:lnSpc>
-            </a:pPr>
-            <a:r>
-              <a:rPr sz="1100" b="0">
-                <a:solidFill>
-                  <a:srgbClr val="1A1A1A"/>
-                </a:solidFill>
-                <a:latin typeface="Calibri"/>
-              </a:rPr>
-              <a:t>• 18-sheet Excel companion (Quick_Reference.xlsx) for offline analysts</a:t>
-            </a:r>
-          </a:p>
-          <a:p>
-            <a:pPr algn="l">
-              <a:lnSpc>
-                <a:spcPct val="118000"/>
-              </a:lnSpc>
-            </a:pPr>
-            <a:r>
-              <a:rPr sz="1100" b="0">
-                <a:solidFill>
-                  <a:srgbClr val="1A1A1A"/>
-                </a:solidFill>
-                <a:latin typeface="Calibri"/>
-              </a:rPr>
-              <a:t>• Full handover playbook for Glencore IT (Dockerfile + docs/HANDOVER.md)</a:t>
-            </a:r>
-          </a:p>
-          <a:p>
-            <a:pPr algn="l">
-              <a:lnSpc>
-                <a:spcPct val="118000"/>
-              </a:lnSpc>
-            </a:pPr>
-            <a:r>
-              <a:rPr sz="1100" b="0">
-                <a:solidFill>
-                  <a:srgbClr val="1A1A1A"/>
-                </a:solidFill>
-                <a:latin typeface="Calibri"/>
-              </a:rPr>
-              <a:t>• .gitignore protects confidential supplier CSV from public push</a:t>
-            </a:r>
-          </a:p>
-        </p:txBody>
-      </p:sp>
-      <p:sp>
-        <p:nvSpPr>
-          <p:cNvPr id="7" name="TextBox 6"/>
-          <p:cNvSpPr txBox="1"/>
-          <p:nvPr/>
-        </p:nvSpPr>
-        <p:spPr>
-          <a:xfrm>
-            <a:off x="6400800" y="1371600"/>
-            <a:ext cx="5303520" cy="365760"/>
-          </a:xfrm>
-          <a:prstGeom prst="rect">
-            <a:avLst/>
-          </a:prstGeom>
-          <a:noFill/>
-        </p:spPr>
-        <p:txBody>
-          <a:bodyPr wrap="square" anchor="t" lIns="45720" rIns="45720">
-            <a:spAutoFit/>
-          </a:bodyPr>
-          <a:lstStyle/>
-          <a:p>
-            <a:pPr algn="l"/>
-            <a:r>
-              <a:rPr sz="1500" b="1" i="0">
-                <a:solidFill>
-                  <a:srgbClr val="005F73"/>
-                </a:solidFill>
-                <a:latin typeface="Calibri"/>
-              </a:rPr>
-              <a:t>Roadmap</a:t>
-            </a:r>
-          </a:p>
-        </p:txBody>
-      </p:sp>
-      <p:sp>
-        <p:nvSpPr>
-          <p:cNvPr id="8" name="TextBox 7"/>
-          <p:cNvSpPr txBox="1"/>
-          <p:nvPr/>
-        </p:nvSpPr>
-        <p:spPr>
-          <a:xfrm>
-            <a:off x="6400800" y="1783080"/>
-            <a:ext cx="5303520" cy="2377440"/>
-          </a:xfrm>
-          <a:prstGeom prst="rect">
-            <a:avLst/>
-          </a:prstGeom>
-          <a:noFill/>
-        </p:spPr>
-        <p:txBody>
-          <a:bodyPr wrap="square">
-            <a:spAutoFit/>
-          </a:bodyPr>
-          <a:lstStyle/>
-          <a:p>
-            <a:pPr algn="l">
-              <a:lnSpc>
-                <a:spcPct val="118000"/>
-              </a:lnSpc>
-            </a:pPr>
-            <a:r>
-              <a:rPr sz="1100" b="0">
-                <a:solidFill>
-                  <a:srgbClr val="1A1A1A"/>
-                </a:solidFill>
-                <a:latin typeface="Calibri"/>
-              </a:rPr>
-              <a:t>• Glencore swaps in their counterparty database for the supplier layer</a:t>
-            </a:r>
-          </a:p>
-          <a:p>
-            <a:pPr algn="l">
-              <a:lnSpc>
-                <a:spcPct val="118000"/>
-              </a:lnSpc>
-            </a:pPr>
-            <a:r>
-              <a:rPr sz="1100" b="0">
-                <a:solidFill>
-                  <a:srgbClr val="1A1A1A"/>
-                </a:solidFill>
-                <a:latin typeface="Calibri"/>
-              </a:rPr>
-              <a:t>• Sub-national CAHRA region resolution (Aqueduct already at province level)</a:t>
-            </a:r>
-          </a:p>
-          <a:p>
-            <a:pPr algn="l">
-              <a:lnSpc>
-                <a:spcPct val="118000"/>
-              </a:lnSpc>
-            </a:pPr>
-            <a:r>
-              <a:rPr sz="1100" b="0">
-                <a:solidFill>
-                  <a:srgbClr val="1A1A1A"/>
-                </a:solidFill>
-                <a:latin typeface="Calibri"/>
-              </a:rPr>
-              <a:t>• Live Aqueduct API for water-pollution UCW + CEP indicators</a:t>
-            </a:r>
-          </a:p>
-          <a:p>
-            <a:pPr algn="l">
-              <a:lnSpc>
-                <a:spcPct val="118000"/>
-              </a:lnSpc>
-            </a:pPr>
-            <a:r>
-              <a:rPr sz="1100" b="0">
-                <a:solidFill>
-                  <a:srgbClr val="1A1A1A"/>
-                </a:solidFill>
-                <a:latin typeface="Calibri"/>
-              </a:rPr>
-              <a:t>• Translate scoring engine into Power BI / DAX for Glencore BI stack</a:t>
-            </a:r>
-          </a:p>
-          <a:p>
-            <a:pPr algn="l">
-              <a:lnSpc>
-                <a:spcPct val="118000"/>
-              </a:lnSpc>
-            </a:pPr>
-            <a:r>
-              <a:rPr sz="1100" b="0">
-                <a:solidFill>
-                  <a:srgbClr val="1A1A1A"/>
-                </a:solidFill>
-                <a:latin typeface="Calibri"/>
-              </a:rPr>
-              <a:t>• Annual data refresh cycle with automated CI</a:t>
-            </a:r>
-          </a:p>
-        </p:txBody>
-      </p:sp>
-      <p:sp>
-        <p:nvSpPr>
-          <p:cNvPr id="9" name="TextBox 8"/>
-          <p:cNvSpPr txBox="1"/>
-          <p:nvPr/>
-        </p:nvSpPr>
-        <p:spPr>
-          <a:xfrm>
-            <a:off x="457200" y="4297680"/>
-            <a:ext cx="11247120" cy="365760"/>
-          </a:xfrm>
-          <a:prstGeom prst="rect">
-            <a:avLst/>
-          </a:prstGeom>
-          <a:noFill/>
-        </p:spPr>
-        <p:txBody>
-          <a:bodyPr wrap="square" anchor="t" lIns="45720" rIns="45720">
-            <a:spAutoFit/>
-          </a:bodyPr>
-          <a:lstStyle/>
-          <a:p>
-            <a:pPr algn="l"/>
-            <a:r>
-              <a:rPr sz="1400" b="1" i="0">
-                <a:solidFill>
-                  <a:srgbClr val="005F73"/>
-                </a:solidFill>
-                <a:latin typeface="Calibri"/>
-              </a:rPr>
-              <a:t>Selected references</a:t>
-            </a:r>
-          </a:p>
-        </p:txBody>
-      </p:sp>
-      <p:sp>
-        <p:nvSpPr>
-          <p:cNvPr id="10" name="TextBox 9"/>
-          <p:cNvSpPr txBox="1"/>
-          <p:nvPr/>
-        </p:nvSpPr>
-        <p:spPr>
-          <a:xfrm>
-            <a:off x="457200" y="4617720"/>
-            <a:ext cx="11247120" cy="1828800"/>
-          </a:xfrm>
-          <a:prstGeom prst="rect">
-            <a:avLst/>
-          </a:prstGeom>
-          <a:noFill/>
-        </p:spPr>
-        <p:txBody>
-          <a:bodyPr wrap="square">
-            <a:spAutoFit/>
-          </a:bodyPr>
-          <a:lstStyle/>
-          <a:p>
-            <a:pPr algn="l">
-              <a:lnSpc>
-                <a:spcPct val="118000"/>
-              </a:lnSpc>
-            </a:pPr>
-            <a:r>
-              <a:rPr sz="950" b="0">
-                <a:solidFill>
-                  <a:srgbClr val="1A1A1A"/>
-                </a:solidFill>
-                <a:latin typeface="Calibri"/>
-              </a:rPr>
-              <a:t>• OECD (2016). Due Diligence Guidance for Responsible Supply Chains of Minerals from Conflict-Affected and High-Risk Areas, 3rd ed. oecd.org/daf/inv/mne/mining.htm</a:t>
-            </a:r>
-          </a:p>
-          <a:p>
-            <a:pPr algn="l">
-              <a:lnSpc>
-                <a:spcPct val="118000"/>
-              </a:lnSpc>
-            </a:pPr>
-            <a:r>
-              <a:rPr sz="950" b="0">
-                <a:solidFill>
-                  <a:srgbClr val="1A1A1A"/>
-                </a:solidFill>
-                <a:latin typeface="Calibri"/>
-              </a:rPr>
-              <a:t>• IEA (2024). Global Critical Minerals Outlook 2024. iea.org</a:t>
-            </a:r>
-          </a:p>
-          <a:p>
-            <a:pPr algn="l">
-              <a:lnSpc>
-                <a:spcPct val="118000"/>
-              </a:lnSpc>
-            </a:pPr>
-            <a:r>
-              <a:rPr sz="950" b="0">
-                <a:solidFill>
-                  <a:srgbClr val="1A1A1A"/>
-                </a:solidFill>
-                <a:latin typeface="Calibri"/>
-              </a:rPr>
-              <a:t>• USGS (2024). Mineral Commodity Summaries 2024. pubs.usgs.gov/periodicals/mcs2024</a:t>
-            </a:r>
-          </a:p>
-          <a:p>
-            <a:pPr algn="l">
-              <a:lnSpc>
-                <a:spcPct val="118000"/>
-              </a:lnSpc>
-            </a:pPr>
-            <a:r>
-              <a:rPr sz="950" b="0">
-                <a:solidFill>
-                  <a:srgbClr val="1A1A1A"/>
-                </a:solidFill>
-                <a:latin typeface="Calibri"/>
-              </a:rPr>
-              <a:t>• USGS (2022). 2022 List of Critical Minerals. usgs.gov/news/national-news-release/us-geological-survey-releases-2022-list-critical-minerals</a:t>
-            </a:r>
-          </a:p>
-          <a:p>
-            <a:pPr algn="l">
-              <a:lnSpc>
-                <a:spcPct val="118000"/>
-              </a:lnSpc>
-            </a:pPr>
-            <a:r>
-              <a:rPr sz="950" b="0">
-                <a:solidFill>
-                  <a:srgbClr val="1A1A1A"/>
-                </a:solidFill>
-                <a:latin typeface="Calibri"/>
-              </a:rPr>
-              <a:t>• Glencore (2024). Supply Chain Due Diligence Procedure — Metals and Minerals.</a:t>
-            </a:r>
-          </a:p>
-          <a:p>
-            <a:pPr algn="l">
-              <a:lnSpc>
-                <a:spcPct val="118000"/>
-              </a:lnSpc>
-            </a:pPr>
-            <a:r>
-              <a:rPr sz="950" b="0">
-                <a:solidFill>
-                  <a:srgbClr val="1A1A1A"/>
-                </a:solidFill>
-                <a:latin typeface="Calibri"/>
-              </a:rPr>
-              <a:t>• Glencore (2025). CAHRA List 2025 (updated 27.02.2025).</a:t>
-            </a:r>
-          </a:p>
-          <a:p>
-            <a:pPr algn="l">
-              <a:lnSpc>
-                <a:spcPct val="118000"/>
-              </a:lnSpc>
-            </a:pPr>
-            <a:r>
-              <a:rPr sz="950" b="0">
-                <a:solidFill>
-                  <a:srgbClr val="1A1A1A"/>
-                </a:solidFill>
-                <a:latin typeface="Calibri"/>
-              </a:rPr>
-              <a:t>• Yale EPI 2024 · WRI Aqueduct 4.0 · WHO Ambient Air Quality DB · IUCN Red List · WDPA · ISRIC SoilGrids · Global Energy Monitor · Global Tailings Portal · ENCORE · IFC EHS Guidelines · INFORM Risk Index 2024.</a:t>
-            </a:r>
-          </a:p>
-        </p:txBody>
-      </p:sp>
-      <p:sp>
-        <p:nvSpPr>
-          <p:cNvPr id="11" name="TextBox 10"/>
-          <p:cNvSpPr txBox="1"/>
-          <p:nvPr/>
-        </p:nvSpPr>
-        <p:spPr>
-          <a:xfrm>
-            <a:off x="457200" y="6446520"/>
-            <a:ext cx="7315200" cy="320040"/>
-          </a:xfrm>
-          <a:prstGeom prst="rect">
-            <a:avLst/>
-          </a:prstGeom>
-          <a:noFill/>
-        </p:spPr>
-        <p:txBody>
-          <a:bodyPr wrap="square" anchor="t" lIns="45720" rIns="45720">
-            <a:spAutoFit/>
-          </a:bodyPr>
-          <a:lstStyle/>
-          <a:p>
-            <a:pPr algn="l"/>
-            <a:r>
-              <a:rPr sz="900" b="0" i="1">
-                <a:solidFill>
-                  <a:srgbClr val="555555"/>
-                </a:solidFill>
-                <a:latin typeface="Calibri"/>
-              </a:rPr>
-              <a:t>Glencore Environmental Risk Tool — NYU SPS MS Global Affairs</a:t>
-            </a:r>
-          </a:p>
-        </p:txBody>
-      </p:sp>
-      <p:sp>
-        <p:nvSpPr>
-          <p:cNvPr id="12" name="TextBox 11"/>
-          <p:cNvSpPr txBox="1"/>
-          <p:nvPr/>
-        </p:nvSpPr>
-        <p:spPr>
-          <a:xfrm>
-            <a:off x="10515600" y="6446520"/>
-            <a:ext cx="1188720" cy="320040"/>
-          </a:xfrm>
-          <a:prstGeom prst="rect">
-            <a:avLst/>
-          </a:prstGeom>
-          <a:noFill/>
-        </p:spPr>
-        <p:txBody>
-          <a:bodyPr wrap="square" anchor="t" lIns="45720" rIns="45720">
-            <a:spAutoFit/>
-          </a:bodyPr>
-          <a:lstStyle/>
-          <a:p>
-            <a:pPr algn="r"/>
-            <a:r>
-              <a:rPr sz="900" b="0" i="0">
-                <a:solidFill>
-                  <a:srgbClr val="555555"/>
-                </a:solidFill>
-                <a:latin typeface="Calibri"/>
-              </a:rPr>
-              <a:t>9 / 9</a:t>
+              <a:t>7 / 7</a:t>
             </a:r>
           </a:p>
         </p:txBody>

</xml_diff>